<commit_message>
feat: robo Selic validado, instalador Windows, slides com IAs gratuitas e QR
- corrige consulta ao BCB (ultimos/N limitado a 20 -> consulta por periodo)
- contingencia (ultima consulta salva / exemplo) sempre avisada na tela, Excel e PDF
- corrige formato da aba Resumo (valores apareciam como 1475,00%)
- instalador sem Python/administrador, com atalhos e desinstalacao
- slide 07 com IAs gratuitas, slides 08-10 com dados reais, QR definitivo
- prompt completo validado (reproduz o mesmo PDF), guia, apostila e roteiro atualizados

Co-Authored-By: Claude Opus 5.5 <noreply@anthropic.com>
</commit_message>
<xml_diff>
--- a/apresentacao/BMA-Oficina-de-Robos.pptx
+++ b/apresentacao/BMA-Oficina-de-Robos.pptx
@@ -14,6 +14,7 @@
     <p:sldId id="259" r:id="rId5"/>
     <p:sldId id="260" r:id="rId6"/>
     <p:sldId id="261" r:id="rId7"/>
+    <p:sldId id="270" r:id="rId21"/>
     <p:sldId id="262" r:id="rId8"/>
     <p:sldId id="263" r:id="rId9"/>
     <p:sldId id="264" r:id="rId10"/>
@@ -184,22 +185,22 @@
               <c:strCache>
                 <c:ptCount val="6"/>
                 <c:pt idx="0">
-                  <c:v>21/05</c:v>
+                  <c:v>12/08</c:v>
                 </c:pt>
                 <c:pt idx="1">
-                  <c:v>27/05</c:v>
+                  <c:v>20/08</c:v>
                 </c:pt>
                 <c:pt idx="2">
-                  <c:v>02/06</c:v>
+                  <c:v>28/08</c:v>
                 </c:pt>
                 <c:pt idx="3">
-                  <c:v>06/06</c:v>
+                  <c:v>08/09</c:v>
                 </c:pt>
                 <c:pt idx="4">
-                  <c:v>12/06</c:v>
+                  <c:v>16/09</c:v>
                 </c:pt>
                 <c:pt idx="5">
-                  <c:v>18/06</c:v>
+                  <c:v>23/09</c:v>
                 </c:pt>
               </c:strCache>
             </c:strRef>
@@ -211,22 +212,22 @@
                 <c:formatCode>General</c:formatCode>
                 <c:ptCount val="6"/>
                 <c:pt idx="0">
-                  <c:v>14.5</c:v>
+                  <c:v>13.9</c:v>
                 </c:pt>
                 <c:pt idx="1">
-                  <c:v>14.5</c:v>
+                  <c:v>13.9</c:v>
                 </c:pt>
                 <c:pt idx="2">
-                  <c:v>14.55</c:v>
+                  <c:v>13.9</c:v>
                 </c:pt>
                 <c:pt idx="3">
-                  <c:v>14.75</c:v>
+                  <c:v>13.9</c:v>
                 </c:pt>
                 <c:pt idx="4">
-                  <c:v>14.75</c:v>
+                  <c:v>13.9</c:v>
                 </c:pt>
                 <c:pt idx="5">
-                  <c:v>14.75</c:v>
+                  <c:v>13.65</c:v>
                 </c:pt>
               </c:numCache>
             </c:numRef>
@@ -297,8 +298,8 @@
         <c:axId val="2094734552"/>
         <c:scaling>
           <c:orientation val="minMax"/>
-          <c:max val="15"/>
-          <c:min val="14"/>
+          <c:max val="14.0"/>
+          <c:min val="13.5"/>
         </c:scaling>
         <c:delete val="0"/>
         <c:axPos val="l"/>
@@ -313,7 +314,7 @@
             </a:ln>
           </c:spPr>
         </c:majorGridlines>
-        <c:numFmt formatCode="General" sourceLinked="0"/>
+        <c:numFmt formatCode="0.00" sourceLinked="0"/>
         <c:majorTickMark val="out"/>
         <c:minorTickMark val="none"/>
         <c:tickLblPos val="nextTo"/>
@@ -344,6 +345,7 @@
         <c:crossAx val="2094734554"/>
         <c:crosses val="autoZero"/>
         <c:crossBetween val="between"/>
+        <c:majorUnit val="0.05"/>
       </c:valAx>
       <c:spPr>
         <a:noFill/>
@@ -2341,6 +2343,878 @@
 
 <file path=ppt/slides/slide10.xml><?xml version="1.0" encoding="utf-8"?>
 <p:sld xmlns:a="http://schemas.openxmlformats.org/drawingml/2006/main" xmlns:r="http://schemas.openxmlformats.org/officeDocument/2006/relationships" xmlns:p="http://schemas.openxmlformats.org/presentationml/2006/main">
+  <p:cSld name="Slide 9">
+    <p:bg>
+      <p:bgPr>
+        <a:solidFill>
+          <a:srgbClr val="0B1D3A"/>
+        </a:solidFill>
+        <a:effectLst/>
+      </p:bgPr>
+    </p:bg>
+    <p:spTree>
+      <p:nvGrpSpPr>
+        <p:cNvPr id="1" name=""/>
+        <p:cNvGrpSpPr/>
+        <p:nvPr/>
+      </p:nvGrpSpPr>
+      <p:grpSpPr>
+        <a:xfrm>
+          <a:off x="0" y="0"/>
+          <a:ext cx="0" cy="0"/>
+          <a:chOff x="0" y="0"/>
+          <a:chExt cx="0" cy="0"/>
+        </a:xfrm>
+      </p:grpSpPr>
+      <p:pic>
+        <p:nvPicPr>
+          <p:cNvPr id="2" name="Image 0" descr="preencoded.png"/>
+          <p:cNvPicPr>
+            <a:picLocks noChangeAspect="1"/>
+          </p:cNvPicPr>
+          <p:nvPr/>
+        </p:nvPicPr>
+        <p:blipFill>
+          <a:blip r:embed="rId3"/>
+          <a:stretch>
+            <a:fillRect/>
+          </a:stretch>
+        </p:blipFill>
+        <p:spPr>
+          <a:xfrm>
+            <a:off x="502920" y="384048"/>
+            <a:ext cx="1234440" cy="585216"/>
+          </a:xfrm>
+          <a:prstGeom prst="rect">
+            <a:avLst/>
+          </a:prstGeom>
+        </p:spPr>
+      </p:pic>
+      <p:sp>
+        <p:nvSpPr>
+          <p:cNvPr id="3" name="Text 0"/>
+          <p:cNvSpPr/>
+          <p:nvPr/>
+        </p:nvSpPr>
+        <p:spPr>
+          <a:xfrm>
+            <a:off x="10607040" y="411480"/>
+            <a:ext cx="1097280" cy="365760"/>
+          </a:xfrm>
+          <a:prstGeom prst="rect">
+            <a:avLst/>
+          </a:prstGeom>
+          <a:noFill/>
+          <a:ln/>
+        </p:spPr>
+        <p:txBody>
+          <a:bodyPr wrap="square" rtlCol="0" anchor="ctr"/>
+          <a:lstStyle/>
+          <a:p>
+            <a:pPr marL="0" indent="0" algn="r">
+              <a:buNone/>
+            </a:pPr>
+            <a:r>
+              <a:rPr lang="en-US" sz="1600" dirty="0">
+                <a:solidFill>
+                  <a:srgbClr val="D1D5DB"/>
+                </a:solidFill>
+                <a:latin typeface="Arial" pitchFamily="34" charset="0"/>
+                <a:ea typeface="Arial" pitchFamily="34" charset="-122"/>
+                <a:cs typeface="Arial" pitchFamily="34" charset="-120"/>
+              </a:rPr>
+              <a:t>10</a:t>
+            </a:r>
+            <a:endParaRPr lang="en-US" sz="1600" dirty="0"/>
+          </a:p>
+        </p:txBody>
+      </p:sp>
+      <p:sp>
+        <p:nvSpPr>
+          <p:cNvPr id="4" name="Text 1"/>
+          <p:cNvSpPr/>
+          <p:nvPr/>
+        </p:nvSpPr>
+        <p:spPr>
+          <a:xfrm>
+            <a:off x="502920" y="1234440"/>
+            <a:ext cx="11155680" cy="822960"/>
+          </a:xfrm>
+          <a:prstGeom prst="rect">
+            <a:avLst/>
+          </a:prstGeom>
+          <a:noFill/>
+          <a:ln/>
+        </p:spPr>
+        <p:txBody>
+          <a:bodyPr wrap="square" rtlCol="0" anchor="ctr"/>
+          <a:lstStyle/>
+          <a:p>
+            <a:pPr marL="0" indent="0">
+              <a:buNone/>
+            </a:pPr>
+            <a:r>
+              <a:rPr lang="en-US" sz="4000" kern="0" spc="-50" dirty="0">
+                <a:solidFill>
+                  <a:srgbClr val="FFFFFF"/>
+                </a:solidFill>
+                <a:latin typeface="Arial Black" pitchFamily="34" charset="0"/>
+                <a:ea typeface="Arial Black" pitchFamily="34" charset="-122"/>
+                <a:cs typeface="Arial Black" pitchFamily="34" charset="-120"/>
+              </a:rPr>
+              <a:t>RESUMO EXECUTIVO</a:t>
+            </a:r>
+            <a:endParaRPr lang="en-US" sz="4000" dirty="0"/>
+          </a:p>
+        </p:txBody>
+      </p:sp>
+      <p:sp>
+        <p:nvSpPr>
+          <p:cNvPr id="5" name="Shape 2"/>
+          <p:cNvSpPr/>
+          <p:nvPr/>
+        </p:nvSpPr>
+        <p:spPr>
+          <a:xfrm>
+            <a:off x="502920" y="2148840"/>
+            <a:ext cx="6035040" cy="713232"/>
+          </a:xfrm>
+          <a:prstGeom prst="roundRect">
+            <a:avLst>
+              <a:gd name="adj" fmla="val 10256"/>
+            </a:avLst>
+          </a:prstGeom>
+          <a:solidFill>
+            <a:srgbClr val="12294F"/>
+          </a:solidFill>
+          <a:ln w="12700">
+            <a:solidFill>
+              <a:srgbClr val="1E3A6B"/>
+            </a:solidFill>
+            <a:prstDash val="solid"/>
+          </a:ln>
+        </p:spPr>
+        <p:txBody>
+          <a:bodyPr/>
+          <a:lstStyle/>
+          <a:p>
+            <a:endParaRPr lang="pt-BR"/>
+          </a:p>
+        </p:txBody>
+      </p:sp>
+      <p:sp>
+        <p:nvSpPr>
+          <p:cNvPr id="6" name="Shape 3"/>
+          <p:cNvSpPr/>
+          <p:nvPr/>
+        </p:nvSpPr>
+        <p:spPr>
+          <a:xfrm>
+            <a:off x="502920" y="2148840"/>
+            <a:ext cx="82296" cy="713232"/>
+          </a:xfrm>
+          <a:prstGeom prst="rect">
+            <a:avLst/>
+          </a:prstGeom>
+          <a:solidFill>
+            <a:srgbClr val="F28C2B"/>
+          </a:solidFill>
+          <a:ln/>
+        </p:spPr>
+        <p:txBody>
+          <a:bodyPr/>
+          <a:lstStyle/>
+          <a:p>
+            <a:endParaRPr lang="pt-BR"/>
+          </a:p>
+        </p:txBody>
+      </p:sp>
+      <p:sp>
+        <p:nvSpPr>
+          <p:cNvPr id="7" name="Text 4"/>
+          <p:cNvSpPr/>
+          <p:nvPr/>
+        </p:nvSpPr>
+        <p:spPr>
+          <a:xfrm>
+            <a:off x="777240" y="2194560"/>
+            <a:ext cx="5486400" cy="292608"/>
+          </a:xfrm>
+          <a:prstGeom prst="rect">
+            <a:avLst/>
+          </a:prstGeom>
+          <a:noFill/>
+          <a:ln/>
+        </p:spPr>
+        <p:txBody>
+          <a:bodyPr wrap="square" rtlCol="0" anchor="ctr"/>
+          <a:lstStyle/>
+          <a:p>
+            <a:pPr marL="0" indent="0">
+              <a:buNone/>
+            </a:pPr>
+            <a:r>
+              <a:rPr lang="en-US" sz="1400" dirty="0">
+                <a:solidFill>
+                  <a:srgbClr val="D1D5DB"/>
+                </a:solidFill>
+                <a:latin typeface="Arial" pitchFamily="34" charset="0"/>
+                <a:ea typeface="Arial" pitchFamily="34" charset="-122"/>
+                <a:cs typeface="Arial" pitchFamily="34" charset="-120"/>
+              </a:rPr>
+              <a:t>Primeiro valor (12/08/2026)</a:t>
+            </a:r>
+            <a:endParaRPr lang="en-US" sz="1400" dirty="0"/>
+          </a:p>
+        </p:txBody>
+      </p:sp>
+      <p:sp>
+        <p:nvSpPr>
+          <p:cNvPr id="8" name="Text 5"/>
+          <p:cNvSpPr/>
+          <p:nvPr/>
+        </p:nvSpPr>
+        <p:spPr>
+          <a:xfrm>
+            <a:off x="777240" y="2468880"/>
+            <a:ext cx="5486400" cy="347472"/>
+          </a:xfrm>
+          <a:prstGeom prst="rect">
+            <a:avLst/>
+          </a:prstGeom>
+          <a:noFill/>
+          <a:ln/>
+        </p:spPr>
+        <p:txBody>
+          <a:bodyPr wrap="square" rtlCol="0" anchor="ctr"/>
+          <a:lstStyle/>
+          <a:p>
+            <a:pPr marL="0" indent="0">
+              <a:buNone/>
+            </a:pPr>
+            <a:r>
+              <a:rPr lang="en-US" sz="1900" b="1" dirty="0">
+                <a:solidFill>
+                  <a:srgbClr val="FFFFFF"/>
+                </a:solidFill>
+                <a:latin typeface="Arial" pitchFamily="34" charset="0"/>
+                <a:ea typeface="Arial" pitchFamily="34" charset="-122"/>
+                <a:cs typeface="Arial" pitchFamily="34" charset="-120"/>
+              </a:rPr>
+              <a:t>13,90%</a:t>
+            </a:r>
+            <a:endParaRPr lang="en-US" sz="1900" dirty="0"/>
+          </a:p>
+        </p:txBody>
+      </p:sp>
+      <p:sp>
+        <p:nvSpPr>
+          <p:cNvPr id="9" name="Shape 6"/>
+          <p:cNvSpPr/>
+          <p:nvPr/>
+        </p:nvSpPr>
+        <p:spPr>
+          <a:xfrm>
+            <a:off x="502920" y="2990088"/>
+            <a:ext cx="6035040" cy="713232"/>
+          </a:xfrm>
+          <a:prstGeom prst="roundRect">
+            <a:avLst>
+              <a:gd name="adj" fmla="val 10256"/>
+            </a:avLst>
+          </a:prstGeom>
+          <a:solidFill>
+            <a:srgbClr val="12294F"/>
+          </a:solidFill>
+          <a:ln w="12700">
+            <a:solidFill>
+              <a:srgbClr val="1E3A6B"/>
+            </a:solidFill>
+            <a:prstDash val="solid"/>
+          </a:ln>
+        </p:spPr>
+        <p:txBody>
+          <a:bodyPr/>
+          <a:lstStyle/>
+          <a:p>
+            <a:endParaRPr lang="pt-BR"/>
+          </a:p>
+        </p:txBody>
+      </p:sp>
+      <p:sp>
+        <p:nvSpPr>
+          <p:cNvPr id="10" name="Shape 7"/>
+          <p:cNvSpPr/>
+          <p:nvPr/>
+        </p:nvSpPr>
+        <p:spPr>
+          <a:xfrm>
+            <a:off x="502920" y="2990088"/>
+            <a:ext cx="82296" cy="713232"/>
+          </a:xfrm>
+          <a:prstGeom prst="rect">
+            <a:avLst/>
+          </a:prstGeom>
+          <a:solidFill>
+            <a:srgbClr val="F28C2B"/>
+          </a:solidFill>
+          <a:ln/>
+        </p:spPr>
+        <p:txBody>
+          <a:bodyPr/>
+          <a:lstStyle/>
+          <a:p>
+            <a:endParaRPr lang="pt-BR"/>
+          </a:p>
+        </p:txBody>
+      </p:sp>
+      <p:sp>
+        <p:nvSpPr>
+          <p:cNvPr id="11" name="Text 8"/>
+          <p:cNvSpPr/>
+          <p:nvPr/>
+        </p:nvSpPr>
+        <p:spPr>
+          <a:xfrm>
+            <a:off x="777240" y="3035808"/>
+            <a:ext cx="5486400" cy="292608"/>
+          </a:xfrm>
+          <a:prstGeom prst="rect">
+            <a:avLst/>
+          </a:prstGeom>
+          <a:noFill/>
+          <a:ln/>
+        </p:spPr>
+        <p:txBody>
+          <a:bodyPr wrap="square" rtlCol="0" anchor="ctr"/>
+          <a:lstStyle/>
+          <a:p>
+            <a:pPr marL="0" indent="0">
+              <a:buNone/>
+            </a:pPr>
+            <a:r>
+              <a:rPr lang="en-US" sz="1400" dirty="0">
+                <a:solidFill>
+                  <a:srgbClr val="D1D5DB"/>
+                </a:solidFill>
+                <a:latin typeface="Arial" pitchFamily="34" charset="0"/>
+                <a:ea typeface="Arial" pitchFamily="34" charset="-122"/>
+                <a:cs typeface="Arial" pitchFamily="34" charset="-120"/>
+              </a:rPr>
+              <a:t>Último valor (23/09/2026)</a:t>
+            </a:r>
+            <a:endParaRPr lang="en-US" sz="1400" dirty="0"/>
+          </a:p>
+        </p:txBody>
+      </p:sp>
+      <p:sp>
+        <p:nvSpPr>
+          <p:cNvPr id="12" name="Text 9"/>
+          <p:cNvSpPr/>
+          <p:nvPr/>
+        </p:nvSpPr>
+        <p:spPr>
+          <a:xfrm>
+            <a:off x="777240" y="3310128"/>
+            <a:ext cx="5486400" cy="347472"/>
+          </a:xfrm>
+          <a:prstGeom prst="rect">
+            <a:avLst/>
+          </a:prstGeom>
+          <a:noFill/>
+          <a:ln/>
+        </p:spPr>
+        <p:txBody>
+          <a:bodyPr wrap="square" rtlCol="0" anchor="ctr"/>
+          <a:lstStyle/>
+          <a:p>
+            <a:pPr marL="0" indent="0">
+              <a:buNone/>
+            </a:pPr>
+            <a:r>
+              <a:rPr lang="en-US" sz="1900" b="1" dirty="0">
+                <a:solidFill>
+                  <a:srgbClr val="FFFFFF"/>
+                </a:solidFill>
+                <a:latin typeface="Arial" pitchFamily="34" charset="0"/>
+                <a:ea typeface="Arial" pitchFamily="34" charset="-122"/>
+                <a:cs typeface="Arial" pitchFamily="34" charset="-120"/>
+              </a:rPr>
+              <a:t>13,65%</a:t>
+            </a:r>
+            <a:endParaRPr lang="en-US" sz="1900" dirty="0"/>
+          </a:p>
+        </p:txBody>
+      </p:sp>
+      <p:sp>
+        <p:nvSpPr>
+          <p:cNvPr id="13" name="Shape 10"/>
+          <p:cNvSpPr/>
+          <p:nvPr/>
+        </p:nvSpPr>
+        <p:spPr>
+          <a:xfrm>
+            <a:off x="502920" y="3831336"/>
+            <a:ext cx="6035040" cy="713232"/>
+          </a:xfrm>
+          <a:prstGeom prst="roundRect">
+            <a:avLst>
+              <a:gd name="adj" fmla="val 10256"/>
+            </a:avLst>
+          </a:prstGeom>
+          <a:solidFill>
+            <a:srgbClr val="12294F"/>
+          </a:solidFill>
+          <a:ln w="12700">
+            <a:solidFill>
+              <a:srgbClr val="1E3A6B"/>
+            </a:solidFill>
+            <a:prstDash val="solid"/>
+          </a:ln>
+        </p:spPr>
+        <p:txBody>
+          <a:bodyPr/>
+          <a:lstStyle/>
+          <a:p>
+            <a:endParaRPr lang="pt-BR"/>
+          </a:p>
+        </p:txBody>
+      </p:sp>
+      <p:sp>
+        <p:nvSpPr>
+          <p:cNvPr id="14" name="Shape 11"/>
+          <p:cNvSpPr/>
+          <p:nvPr/>
+        </p:nvSpPr>
+        <p:spPr>
+          <a:xfrm>
+            <a:off x="502920" y="3831336"/>
+            <a:ext cx="82296" cy="713232"/>
+          </a:xfrm>
+          <a:prstGeom prst="rect">
+            <a:avLst/>
+          </a:prstGeom>
+          <a:solidFill>
+            <a:srgbClr val="F28C2B"/>
+          </a:solidFill>
+          <a:ln/>
+        </p:spPr>
+        <p:txBody>
+          <a:bodyPr/>
+          <a:lstStyle/>
+          <a:p>
+            <a:endParaRPr lang="pt-BR"/>
+          </a:p>
+        </p:txBody>
+      </p:sp>
+      <p:sp>
+        <p:nvSpPr>
+          <p:cNvPr id="15" name="Text 12"/>
+          <p:cNvSpPr/>
+          <p:nvPr/>
+        </p:nvSpPr>
+        <p:spPr>
+          <a:xfrm>
+            <a:off x="777240" y="3877056"/>
+            <a:ext cx="5486400" cy="292608"/>
+          </a:xfrm>
+          <a:prstGeom prst="rect">
+            <a:avLst/>
+          </a:prstGeom>
+          <a:noFill/>
+          <a:ln/>
+        </p:spPr>
+        <p:txBody>
+          <a:bodyPr wrap="square" rtlCol="0" anchor="ctr"/>
+          <a:lstStyle/>
+          <a:p>
+            <a:pPr marL="0" indent="0">
+              <a:buNone/>
+            </a:pPr>
+            <a:r>
+              <a:rPr lang="en-US" sz="1400" dirty="0">
+                <a:solidFill>
+                  <a:srgbClr val="D1D5DB"/>
+                </a:solidFill>
+                <a:latin typeface="Arial" pitchFamily="34" charset="0"/>
+                <a:ea typeface="Arial" pitchFamily="34" charset="-122"/>
+                <a:cs typeface="Arial" pitchFamily="34" charset="-120"/>
+              </a:rPr>
+              <a:t>Variação no período</a:t>
+            </a:r>
+            <a:endParaRPr lang="en-US" sz="1400" dirty="0"/>
+          </a:p>
+        </p:txBody>
+      </p:sp>
+      <p:sp>
+        <p:nvSpPr>
+          <p:cNvPr id="16" name="Text 13"/>
+          <p:cNvSpPr/>
+          <p:nvPr/>
+        </p:nvSpPr>
+        <p:spPr>
+          <a:xfrm>
+            <a:off x="777240" y="4151376"/>
+            <a:ext cx="5486400" cy="347472"/>
+          </a:xfrm>
+          <a:prstGeom prst="rect">
+            <a:avLst/>
+          </a:prstGeom>
+          <a:noFill/>
+          <a:ln/>
+        </p:spPr>
+        <p:txBody>
+          <a:bodyPr wrap="square" rtlCol="0" anchor="ctr"/>
+          <a:lstStyle/>
+          <a:p>
+            <a:pPr marL="0" indent="0">
+              <a:buNone/>
+            </a:pPr>
+            <a:r>
+              <a:rPr lang="en-US" sz="1900" b="1" dirty="0">
+                <a:solidFill>
+                  <a:srgbClr val="F28C2B"/>
+                </a:solidFill>
+                <a:latin typeface="Arial" pitchFamily="34" charset="0"/>
+                <a:ea typeface="Arial" pitchFamily="34" charset="-122"/>
+                <a:cs typeface="Arial" pitchFamily="34" charset="-120"/>
+              </a:rPr>
+              <a:t>-0,25 p.p. (-1,80%)</a:t>
+            </a:r>
+            <a:endParaRPr lang="en-US" sz="1900" dirty="0"/>
+          </a:p>
+        </p:txBody>
+      </p:sp>
+      <p:sp>
+        <p:nvSpPr>
+          <p:cNvPr id="17" name="Shape 14"/>
+          <p:cNvSpPr/>
+          <p:nvPr/>
+        </p:nvSpPr>
+        <p:spPr>
+          <a:xfrm>
+            <a:off x="502920" y="4672584"/>
+            <a:ext cx="6035040" cy="713232"/>
+          </a:xfrm>
+          <a:prstGeom prst="roundRect">
+            <a:avLst>
+              <a:gd name="adj" fmla="val 10256"/>
+            </a:avLst>
+          </a:prstGeom>
+          <a:solidFill>
+            <a:srgbClr val="12294F"/>
+          </a:solidFill>
+          <a:ln w="12700">
+            <a:solidFill>
+              <a:srgbClr val="1E3A6B"/>
+            </a:solidFill>
+            <a:prstDash val="solid"/>
+          </a:ln>
+        </p:spPr>
+        <p:txBody>
+          <a:bodyPr/>
+          <a:lstStyle/>
+          <a:p>
+            <a:endParaRPr lang="pt-BR"/>
+          </a:p>
+        </p:txBody>
+      </p:sp>
+      <p:sp>
+        <p:nvSpPr>
+          <p:cNvPr id="18" name="Shape 15"/>
+          <p:cNvSpPr/>
+          <p:nvPr/>
+        </p:nvSpPr>
+        <p:spPr>
+          <a:xfrm>
+            <a:off x="502920" y="4672584"/>
+            <a:ext cx="82296" cy="713232"/>
+          </a:xfrm>
+          <a:prstGeom prst="rect">
+            <a:avLst/>
+          </a:prstGeom>
+          <a:solidFill>
+            <a:srgbClr val="F28C2B"/>
+          </a:solidFill>
+          <a:ln/>
+        </p:spPr>
+        <p:txBody>
+          <a:bodyPr/>
+          <a:lstStyle/>
+          <a:p>
+            <a:endParaRPr lang="pt-BR"/>
+          </a:p>
+        </p:txBody>
+      </p:sp>
+      <p:sp>
+        <p:nvSpPr>
+          <p:cNvPr id="19" name="Text 16"/>
+          <p:cNvSpPr/>
+          <p:nvPr/>
+        </p:nvSpPr>
+        <p:spPr>
+          <a:xfrm>
+            <a:off x="777240" y="4718304"/>
+            <a:ext cx="5486400" cy="292608"/>
+          </a:xfrm>
+          <a:prstGeom prst="rect">
+            <a:avLst/>
+          </a:prstGeom>
+          <a:noFill/>
+          <a:ln/>
+        </p:spPr>
+        <p:txBody>
+          <a:bodyPr wrap="square" rtlCol="0" anchor="ctr"/>
+          <a:lstStyle/>
+          <a:p>
+            <a:pPr marL="0" indent="0">
+              <a:buNone/>
+            </a:pPr>
+            <a:r>
+              <a:rPr lang="en-US" sz="1400" dirty="0">
+                <a:solidFill>
+                  <a:srgbClr val="D1D5DB"/>
+                </a:solidFill>
+                <a:latin typeface="Arial" pitchFamily="34" charset="0"/>
+                <a:ea typeface="Arial" pitchFamily="34" charset="-122"/>
+                <a:cs typeface="Arial" pitchFamily="34" charset="-120"/>
+              </a:rPr>
+              <a:t>Maior valor</a:t>
+            </a:r>
+            <a:endParaRPr lang="en-US" sz="1400" dirty="0"/>
+          </a:p>
+        </p:txBody>
+      </p:sp>
+      <p:sp>
+        <p:nvSpPr>
+          <p:cNvPr id="20" name="Text 17"/>
+          <p:cNvSpPr/>
+          <p:nvPr/>
+        </p:nvSpPr>
+        <p:spPr>
+          <a:xfrm>
+            <a:off x="777240" y="4992624"/>
+            <a:ext cx="5486400" cy="347472"/>
+          </a:xfrm>
+          <a:prstGeom prst="rect">
+            <a:avLst/>
+          </a:prstGeom>
+          <a:noFill/>
+          <a:ln/>
+        </p:spPr>
+        <p:txBody>
+          <a:bodyPr wrap="square" rtlCol="0" anchor="ctr"/>
+          <a:lstStyle/>
+          <a:p>
+            <a:pPr marL="0" indent="0">
+              <a:buNone/>
+            </a:pPr>
+            <a:r>
+              <a:rPr lang="en-US" sz="1900" b="1" dirty="0">
+                <a:solidFill>
+                  <a:srgbClr val="FFFFFF"/>
+                </a:solidFill>
+                <a:latin typeface="Arial" pitchFamily="34" charset="0"/>
+                <a:ea typeface="Arial" pitchFamily="34" charset="-122"/>
+                <a:cs typeface="Arial" pitchFamily="34" charset="-120"/>
+              </a:rPr>
+              <a:t>13,90%</a:t>
+            </a:r>
+            <a:endParaRPr lang="en-US" sz="1900" dirty="0"/>
+          </a:p>
+        </p:txBody>
+      </p:sp>
+      <p:sp>
+        <p:nvSpPr>
+          <p:cNvPr id="21" name="Shape 18"/>
+          <p:cNvSpPr/>
+          <p:nvPr/>
+        </p:nvSpPr>
+        <p:spPr>
+          <a:xfrm>
+            <a:off x="502920" y="5513832"/>
+            <a:ext cx="6035040" cy="713232"/>
+          </a:xfrm>
+          <a:prstGeom prst="roundRect">
+            <a:avLst>
+              <a:gd name="adj" fmla="val 10256"/>
+            </a:avLst>
+          </a:prstGeom>
+          <a:solidFill>
+            <a:srgbClr val="12294F"/>
+          </a:solidFill>
+          <a:ln w="12700">
+            <a:solidFill>
+              <a:srgbClr val="1E3A6B"/>
+            </a:solidFill>
+            <a:prstDash val="solid"/>
+          </a:ln>
+        </p:spPr>
+        <p:txBody>
+          <a:bodyPr/>
+          <a:lstStyle/>
+          <a:p>
+            <a:endParaRPr lang="pt-BR"/>
+          </a:p>
+        </p:txBody>
+      </p:sp>
+      <p:sp>
+        <p:nvSpPr>
+          <p:cNvPr id="22" name="Shape 19"/>
+          <p:cNvSpPr/>
+          <p:nvPr/>
+        </p:nvSpPr>
+        <p:spPr>
+          <a:xfrm>
+            <a:off x="502920" y="5513832"/>
+            <a:ext cx="82296" cy="713232"/>
+          </a:xfrm>
+          <a:prstGeom prst="rect">
+            <a:avLst/>
+          </a:prstGeom>
+          <a:solidFill>
+            <a:srgbClr val="F28C2B"/>
+          </a:solidFill>
+          <a:ln/>
+        </p:spPr>
+        <p:txBody>
+          <a:bodyPr/>
+          <a:lstStyle/>
+          <a:p>
+            <a:endParaRPr lang="pt-BR"/>
+          </a:p>
+        </p:txBody>
+      </p:sp>
+      <p:sp>
+        <p:nvSpPr>
+          <p:cNvPr id="23" name="Text 20"/>
+          <p:cNvSpPr/>
+          <p:nvPr/>
+        </p:nvSpPr>
+        <p:spPr>
+          <a:xfrm>
+            <a:off x="777240" y="5559552"/>
+            <a:ext cx="5486400" cy="292608"/>
+          </a:xfrm>
+          <a:prstGeom prst="rect">
+            <a:avLst/>
+          </a:prstGeom>
+          <a:noFill/>
+          <a:ln/>
+        </p:spPr>
+        <p:txBody>
+          <a:bodyPr wrap="square" rtlCol="0" anchor="ctr"/>
+          <a:lstStyle/>
+          <a:p>
+            <a:pPr marL="0" indent="0">
+              <a:buNone/>
+            </a:pPr>
+            <a:r>
+              <a:rPr lang="en-US" sz="1400" dirty="0">
+                <a:solidFill>
+                  <a:srgbClr val="D1D5DB"/>
+                </a:solidFill>
+                <a:latin typeface="Arial" pitchFamily="34" charset="0"/>
+                <a:ea typeface="Arial" pitchFamily="34" charset="-122"/>
+                <a:cs typeface="Arial" pitchFamily="34" charset="-120"/>
+              </a:rPr>
+              <a:t>Menor valor</a:t>
+            </a:r>
+            <a:endParaRPr lang="en-US" sz="1400" dirty="0"/>
+          </a:p>
+        </p:txBody>
+      </p:sp>
+      <p:sp>
+        <p:nvSpPr>
+          <p:cNvPr id="24" name="Text 21"/>
+          <p:cNvSpPr/>
+          <p:nvPr/>
+        </p:nvSpPr>
+        <p:spPr>
+          <a:xfrm>
+            <a:off x="777240" y="5833872"/>
+            <a:ext cx="5486400" cy="347472"/>
+          </a:xfrm>
+          <a:prstGeom prst="rect">
+            <a:avLst/>
+          </a:prstGeom>
+          <a:noFill/>
+          <a:ln/>
+        </p:spPr>
+        <p:txBody>
+          <a:bodyPr wrap="square" rtlCol="0" anchor="ctr"/>
+          <a:lstStyle/>
+          <a:p>
+            <a:pPr marL="0" indent="0">
+              <a:buNone/>
+            </a:pPr>
+            <a:r>
+              <a:rPr lang="en-US" sz="1900" b="1" dirty="0">
+                <a:solidFill>
+                  <a:srgbClr val="FFFFFF"/>
+                </a:solidFill>
+                <a:latin typeface="Arial" pitchFamily="34" charset="0"/>
+                <a:ea typeface="Arial" pitchFamily="34" charset="-122"/>
+                <a:cs typeface="Arial" pitchFamily="34" charset="-120"/>
+              </a:rPr>
+              <a:t>13,65%</a:t>
+            </a:r>
+            <a:endParaRPr lang="en-US" sz="1900" dirty="0"/>
+          </a:p>
+        </p:txBody>
+      </p:sp>
+      <p:sp>
+        <p:nvSpPr>
+          <p:cNvPr id="25" name="Text 22"/>
+          <p:cNvSpPr/>
+          <p:nvPr/>
+        </p:nvSpPr>
+        <p:spPr>
+          <a:xfrm>
+            <a:off x="7040880" y="2377440"/>
+            <a:ext cx="4572000" cy="1828800"/>
+          </a:xfrm>
+          <a:prstGeom prst="rect">
+            <a:avLst/>
+          </a:prstGeom>
+          <a:noFill/>
+          <a:ln/>
+        </p:spPr>
+        <p:txBody>
+          <a:bodyPr wrap="square" rtlCol="0" anchor="ctr"/>
+          <a:lstStyle/>
+          <a:p>
+            <a:pPr marL="0" indent="0">
+              <a:lnSpc>
+                <a:spcPts val="3000"/>
+              </a:lnSpc>
+              <a:buNone/>
+            </a:pPr>
+            <a:r>
+              <a:rPr lang="en-US" sz="1900" dirty="0">
+                <a:solidFill>
+                  <a:srgbClr val="D1D5DB"/>
+                </a:solidFill>
+                <a:latin typeface="Arial" pitchFamily="34" charset="0"/>
+                <a:ea typeface="Arial" pitchFamily="34" charset="-122"/>
+                <a:cs typeface="Arial" pitchFamily="34" charset="-120"/>
+              </a:rPr>
+              <a:t>A Selic anualizada base 252 apresentou queda de 0,25 ponto percentual nas últimas 30 observações, encerrando o período em 13,65%.</a:t>
+            </a:r>
+            <a:endParaRPr lang="en-US" sz="1900" dirty="0"/>
+          </a:p>
+        </p:txBody>
+      </p:sp>
+    </p:spTree>
+  </p:cSld>
+  <p:clrMapOvr>
+    <a:masterClrMapping/>
+  </p:clrMapOvr>
+</p:sld>
+</file>
+
+<file path=ppt/slides/slide11.xml><?xml version="1.0" encoding="utf-8"?>
+<p:sld xmlns:a="http://schemas.openxmlformats.org/drawingml/2006/main" xmlns:r="http://schemas.openxmlformats.org/officeDocument/2006/relationships" xmlns:p="http://schemas.openxmlformats.org/presentationml/2006/main">
   <p:cSld name="Slide 10">
     <p:bg>
       <p:bgPr>
@@ -2421,7 +3295,7 @@
                 <a:ea typeface="Arial" pitchFamily="34" charset="-122"/>
                 <a:cs typeface="Arial" pitchFamily="34" charset="-120"/>
               </a:rPr>
-              <a:t>10</a:t>
+              <a:t>11</a:t>
             </a:r>
             <a:endParaRPr lang="en-US" sz="1600" dirty="0"/>
           </a:p>
@@ -3734,7 +4608,7 @@
 </p:sld>
 </file>
 
-<file path=ppt/slides/slide11.xml><?xml version="1.0" encoding="utf-8"?>
+<file path=ppt/slides/slide12.xml><?xml version="1.0" encoding="utf-8"?>
 <p:sld xmlns:a="http://schemas.openxmlformats.org/drawingml/2006/main" xmlns:r="http://schemas.openxmlformats.org/officeDocument/2006/relationships" xmlns:p="http://schemas.openxmlformats.org/presentationml/2006/main">
   <p:cSld name="Slide 11">
     <p:bg>
@@ -3816,7 +4690,7 @@
                 <a:ea typeface="Arial" pitchFamily="34" charset="-122"/>
                 <a:cs typeface="Arial" pitchFamily="34" charset="-120"/>
               </a:rPr>
-              <a:t>11</a:t>
+              <a:t>12</a:t>
             </a:r>
             <a:endParaRPr lang="en-US" sz="1600" dirty="0"/>
           </a:p>
@@ -4041,7 +4915,7 @@
 </p:sld>
 </file>
 
-<file path=ppt/slides/slide12.xml><?xml version="1.0" encoding="utf-8"?>
+<file path=ppt/slides/slide13.xml><?xml version="1.0" encoding="utf-8"?>
 <p:sld xmlns:a="http://schemas.openxmlformats.org/drawingml/2006/main" xmlns:r="http://schemas.openxmlformats.org/officeDocument/2006/relationships" xmlns:p="http://schemas.openxmlformats.org/presentationml/2006/main">
   <p:cSld name="Slide 12">
     <p:bg>
@@ -4123,7 +4997,7 @@
                 <a:ea typeface="Arial" pitchFamily="34" charset="-122"/>
                 <a:cs typeface="Arial" pitchFamily="34" charset="-120"/>
               </a:rPr>
-              <a:t>12</a:t>
+              <a:t>13</a:t>
             </a:r>
             <a:endParaRPr lang="en-US" sz="1600" dirty="0"/>
           </a:p>
@@ -4399,7 +5273,7 @@
 </p:sld>
 </file>
 
-<file path=ppt/slides/slide13.xml><?xml version="1.0" encoding="utf-8"?>
+<file path=ppt/slides/slide14.xml><?xml version="1.0" encoding="utf-8"?>
 <p:sld xmlns:a="http://schemas.openxmlformats.org/drawingml/2006/main" xmlns:r="http://schemas.openxmlformats.org/officeDocument/2006/relationships" xmlns:p="http://schemas.openxmlformats.org/presentationml/2006/main">
   <p:cSld name="Slide 13">
     <p:bg>
@@ -8838,7 +9712,7 @@
                 <a:ea typeface="Arial" pitchFamily="34" charset="-122"/>
                 <a:cs typeface="Arial" pitchFamily="34" charset="-120"/>
               </a:rPr>
-              <a:t>"Crie um script em Python que consulte a API pública do Banco Central do Brasil (SGS) e obtenha a série 1178 (Selic anualizada base 252) dos últimos 30 dias.</a:t>
+              <a:t>"Crie um programa em Python que consulte a API pública do Banco Central do Brasil (SGS) e obtenha as últimas 30 observações da série 1178 (Selic anualizada base 252).</a:t>
             </a:r>
             <a:endParaRPr lang="en-US" sz="2000" dirty="0"/>
           </a:p>
@@ -8916,7 +9790,7 @@
                 <a:ea typeface="Arial" pitchFamily="34" charset="-122"/>
                 <a:cs typeface="Arial" pitchFamily="34" charset="-120"/>
               </a:rPr>
-              <a:t>•  Tratar erros de conexão e ausência de dados</a:t>
+              <a:t>•  Tratar erros e usar dados de contingência se a internet falhar</a:t>
             </a:r>
             <a:endParaRPr lang="en-US" sz="1900" dirty="0"/>
           </a:p>
@@ -8955,7 +9829,7 @@
                 <a:ea typeface="Arial" pitchFamily="34" charset="-122"/>
                 <a:cs typeface="Arial" pitchFamily="34" charset="-120"/>
               </a:rPr>
-              <a:t>•  Gerar uma planilha Excel com os dados</a:t>
+              <a:t>•  Gerar Excel com as abas Dados e Resumo e um gráfico da Selic</a:t>
             </a:r>
             <a:endParaRPr lang="en-US" sz="1900" dirty="0"/>
           </a:p>
@@ -8994,7 +9868,7 @@
                 <a:ea typeface="Arial" pitchFamily="34" charset="-122"/>
                 <a:cs typeface="Arial" pitchFamily="34" charset="-120"/>
               </a:rPr>
-              <a:t>•  Criar um gráfico da evolução da Selic</a:t>
+              <a:t>•  Criar um relatório PDF com os indicadores e abri-lo ao final</a:t>
             </a:r>
             <a:endParaRPr lang="en-US" sz="1900" dirty="0"/>
           </a:p>
@@ -9033,7 +9907,7 @@
                 <a:ea typeface="Arial" pitchFamily="34" charset="-122"/>
                 <a:cs typeface="Arial" pitchFamily="34" charset="-120"/>
               </a:rPr>
-              <a:t>•  Mostrar um resumo executivo da variação no período"</a:t>
+              <a:t>•  Registrar a execução em log e usar só bibliotecas gratuitas"</a:t>
             </a:r>
             <a:endParaRPr lang="en-US" sz="1900" dirty="0"/>
           </a:p>
@@ -9109,6 +9983,1142 @@
 </file>
 
 <file path=ppt/slides/slide7.xml><?xml version="1.0" encoding="utf-8"?>
+<p:sld xmlns:a="http://schemas.openxmlformats.org/drawingml/2006/main" xmlns:r="http://schemas.openxmlformats.org/officeDocument/2006/relationships" xmlns:p="http://schemas.openxmlformats.org/presentationml/2006/main">
+  <p:cSld name="IAs gratuitas">
+    <p:bg>
+      <p:bgPr>
+        <a:solidFill>
+          <a:srgbClr val="0B1D3A"/>
+        </a:solidFill>
+        <a:effectLst/>
+      </p:bgPr>
+    </p:bg>
+    <p:spTree>
+      <p:nvGrpSpPr>
+        <p:cNvPr id="1" name=""/>
+        <p:cNvGrpSpPr/>
+        <p:nvPr/>
+      </p:nvGrpSpPr>
+      <p:grpSpPr>
+        <a:xfrm>
+          <a:off x="0" y="0"/>
+          <a:ext cx="0" cy="0"/>
+          <a:chOff x="0" y="0"/>
+          <a:chExt cx="0" cy="0"/>
+        </a:xfrm>
+      </p:grpSpPr>
+      <p:pic>
+        <p:nvPicPr>
+          <p:cNvPr id="2" name="Image 0" descr="preencoded.png"/>
+          <p:cNvPicPr>
+            <a:picLocks noChangeAspect="1"/>
+          </p:cNvPicPr>
+          <p:nvPr/>
+        </p:nvPicPr>
+        <p:blipFill>
+          <a:blip r:embed="rId3"/>
+          <a:stretch>
+            <a:fillRect/>
+          </a:stretch>
+        </p:blipFill>
+        <p:spPr>
+          <a:xfrm>
+            <a:off x="502920" y="384048"/>
+            <a:ext cx="1234440" cy="585216"/>
+          </a:xfrm>
+          <a:prstGeom prst="rect">
+            <a:avLst/>
+          </a:prstGeom>
+        </p:spPr>
+      </p:pic>
+      <p:sp>
+        <p:nvSpPr>
+          <p:cNvPr id="3" name="Text 0"/>
+          <p:cNvSpPr/>
+          <p:nvPr/>
+        </p:nvSpPr>
+        <p:spPr>
+          <a:xfrm>
+            <a:off x="10607040" y="411480"/>
+            <a:ext cx="1097280" cy="365760"/>
+          </a:xfrm>
+          <a:prstGeom prst="rect">
+            <a:avLst/>
+          </a:prstGeom>
+          <a:noFill/>
+          <a:ln/>
+        </p:spPr>
+        <p:txBody>
+          <a:bodyPr wrap="square" rtlCol="0" anchor="ctr"/>
+          <a:lstStyle/>
+          <a:p>
+            <a:pPr marL="0" indent="0" algn="r">
+              <a:buNone/>
+            </a:pPr>
+            <a:r>
+              <a:rPr lang="en-US" sz="1600" dirty="0">
+                <a:solidFill>
+                  <a:srgbClr val="D1D5DB"/>
+                </a:solidFill>
+                <a:latin typeface="Arial" pitchFamily="34" charset="0"/>
+                <a:ea typeface="Arial" pitchFamily="34" charset="-122"/>
+                <a:cs typeface="Arial" pitchFamily="34" charset="-120"/>
+              </a:rPr>
+              <a:t>07</a:t>
+            </a:r>
+            <a:endParaRPr lang="en-US" sz="1600" dirty="0"/>
+          </a:p>
+        </p:txBody>
+      </p:sp>
+      <p:sp>
+        <p:nvSpPr>
+          <p:cNvPr id="4" name="Text 1"/>
+          <p:cNvSpPr/>
+          <p:nvPr/>
+        </p:nvSpPr>
+        <p:spPr>
+          <a:xfrm>
+            <a:off x="502920" y="1234440"/>
+            <a:ext cx="11155680" cy="822960"/>
+          </a:xfrm>
+          <a:prstGeom prst="rect">
+            <a:avLst/>
+          </a:prstGeom>
+          <a:noFill/>
+          <a:ln/>
+        </p:spPr>
+        <p:txBody>
+          <a:bodyPr wrap="square" rtlCol="0" anchor="ctr"/>
+          <a:lstStyle/>
+          <a:p>
+            <a:pPr marL="0" indent="0">
+              <a:buNone/>
+            </a:pPr>
+            <a:r>
+              <a:rPr lang="en-US" sz="4000" kern="0" spc="-50" dirty="0">
+                <a:solidFill>
+                  <a:srgbClr val="FFFFFF"/>
+                </a:solidFill>
+                <a:latin typeface="Arial Black" pitchFamily="34" charset="0"/>
+                <a:ea typeface="Arial Black" pitchFamily="34" charset="-122"/>
+                <a:cs typeface="Arial Black" pitchFamily="34" charset="-120"/>
+              </a:rPr>
+              <a:t>IAs GRATUITAS PARA USAR</a:t>
+            </a:r>
+            <a:endParaRPr lang="en-US" sz="4000" dirty="0"/>
+          </a:p>
+        </p:txBody>
+      </p:sp>
+      <p:sp>
+        <p:nvSpPr>
+          <p:cNvPr id="5" name="Text 2"/>
+          <p:cNvSpPr/>
+          <p:nvPr/>
+        </p:nvSpPr>
+        <p:spPr>
+          <a:xfrm>
+            <a:off x="502920" y="2240280"/>
+            <a:ext cx="11155680" cy="731520"/>
+          </a:xfrm>
+          <a:prstGeom prst="rect">
+            <a:avLst/>
+          </a:prstGeom>
+          <a:noFill/>
+          <a:ln/>
+        </p:spPr>
+        <p:txBody>
+          <a:bodyPr wrap="square" rtlCol="0" anchor="ctr"/>
+          <a:lstStyle/>
+          <a:p>
+            <a:r>
+              <a:rPr lang="pt-BR" sz="2200" dirty="0">
+                <a:solidFill>
+                  <a:srgbClr val="F8772E"/>
+                </a:solidFill>
+                <a:latin typeface="Arial" panose="020B0604020202020204" pitchFamily="34" charset="0"/>
+                <a:cs typeface="Arial" panose="020B0604020202020204" pitchFamily="34" charset="0"/>
+              </a:rPr>
+              <a:t>Cole o mesmo prompt em qualquer uma e compare as respostas. Nunca insira dados de clientes, senhas ou informações internas.</a:t>
+            </a:r>
+            <a:endParaRPr lang="en-US" sz="2200" dirty="0">
+              <a:solidFill>
+                <a:srgbClr val="F8772E"/>
+              </a:solidFill>
+              <a:latin typeface="Arial" panose="020B0604020202020204" pitchFamily="34" charset="0"/>
+              <a:cs typeface="Arial" panose="020B0604020202020204" pitchFamily="34" charset="0"/>
+            </a:endParaRPr>
+          </a:p>
+        </p:txBody>
+      </p:sp>
+      <p:sp>
+        <p:nvSpPr>
+          <p:cNvPr id="6" name="Shape 3"/>
+          <p:cNvSpPr/>
+          <p:nvPr/>
+        </p:nvSpPr>
+        <p:spPr>
+          <a:xfrm>
+            <a:off x="502920" y="3200400"/>
+            <a:ext cx="2606040" cy="1463040"/>
+          </a:xfrm>
+          <a:prstGeom prst="roundRect">
+            <a:avLst>
+              <a:gd name="adj" fmla="val 7500"/>
+            </a:avLst>
+          </a:prstGeom>
+          <a:solidFill>
+            <a:srgbClr val="12294F"/>
+          </a:solidFill>
+          <a:ln/>
+        </p:spPr>
+        <p:txBody>
+          <a:bodyPr/>
+          <a:lstStyle/>
+          <a:p>
+            <a:endParaRPr lang="pt-BR"/>
+          </a:p>
+        </p:txBody>
+      </p:sp>
+      <p:sp>
+        <p:nvSpPr>
+          <p:cNvPr id="7" name="Text 4"/>
+          <p:cNvSpPr/>
+          <p:nvPr/>
+        </p:nvSpPr>
+        <p:spPr>
+          <a:xfrm>
+            <a:off x="502920" y="3337560"/>
+            <a:ext cx="2606040" cy="548640"/>
+          </a:xfrm>
+          <a:prstGeom prst="rect">
+            <a:avLst/>
+          </a:prstGeom>
+          <a:noFill/>
+          <a:ln/>
+        </p:spPr>
+        <p:txBody>
+          <a:bodyPr wrap="square" rtlCol="0" anchor="ctr"/>
+          <a:lstStyle/>
+          <a:p>
+            <a:pPr marL="0" indent="0" algn="ctr">
+              <a:buNone/>
+            </a:pPr>
+            <a:r>
+              <a:rPr lang="pt-BR" sz="2000" b="1" dirty="0">
+                <a:solidFill>
+                  <a:srgbClr val="FFFFFF"/>
+                </a:solidFill>
+                <a:latin typeface="Arial" pitchFamily="34" charset="0"/>
+                <a:ea typeface="Arial" pitchFamily="34" charset="-122"/>
+                <a:cs typeface="Arial" pitchFamily="34" charset="-120"/>
+              </a:rPr>
+              <a:t>ChatGPT</a:t>
+            </a:r>
+            <a:endParaRPr lang="en-US" sz="2600" dirty="0"/>
+          </a:p>
+        </p:txBody>
+      </p:sp>
+      <p:sp>
+        <p:nvSpPr>
+          <p:cNvPr id="8" name="Text 5"/>
+          <p:cNvSpPr/>
+          <p:nvPr/>
+        </p:nvSpPr>
+        <p:spPr>
+          <a:xfrm>
+            <a:off x="640080" y="3931920"/>
+            <a:ext cx="2331720" cy="594360"/>
+          </a:xfrm>
+          <a:prstGeom prst="rect">
+            <a:avLst/>
+          </a:prstGeom>
+          <a:noFill/>
+          <a:ln/>
+        </p:spPr>
+        <p:txBody>
+          <a:bodyPr wrap="square" rtlCol="0" anchor="t"/>
+          <a:lstStyle/>
+          <a:p>
+            <a:pPr marL="0" indent="0" algn="ctr">
+              <a:buNone/>
+            </a:pPr>
+            <a:r>
+              <a:rPr lang="pt-BR" sz="1400" dirty="0">
+                <a:solidFill>
+                  <a:srgbClr val="D1D5DB"/>
+                </a:solidFill>
+                <a:latin typeface="Arial" pitchFamily="34" charset="0"/>
+                <a:ea typeface="Arial" pitchFamily="34" charset="-122"/>
+                <a:cs typeface="Arial" pitchFamily="34" charset="-120"/>
+              </a:rPr>
+              <a:t>OpenAI · código e textos</a:t>
+            </a:r>
+            <a:br>
+              <a:rPr lang="pt-BR" sz="1300"/>
+            </a:br>
+            <a:r>
+              <a:rPr lang="pt-BR" sz="1300" dirty="0">
+                <a:solidFill>
+                  <a:srgbClr val="F28C2B"/>
+                </a:solidFill>
+                <a:latin typeface="Arial" pitchFamily="34" charset="0"/>
+                <a:cs typeface="Arial" pitchFamily="34" charset="-120"/>
+              </a:rPr>
+              <a:t>chatgpt.com</a:t>
+            </a:r>
+            <a:endParaRPr lang="en-US" sz="1600" dirty="0"/>
+          </a:p>
+        </p:txBody>
+      </p:sp>
+      <p:sp>
+        <p:nvSpPr>
+          <p:cNvPr id="9" name="Shape 6"/>
+          <p:cNvSpPr/>
+          <p:nvPr/>
+        </p:nvSpPr>
+        <p:spPr>
+          <a:xfrm>
+            <a:off x="3355848" y="3200400"/>
+            <a:ext cx="2606040" cy="1463040"/>
+          </a:xfrm>
+          <a:prstGeom prst="roundRect">
+            <a:avLst>
+              <a:gd name="adj" fmla="val 7500"/>
+            </a:avLst>
+          </a:prstGeom>
+          <a:solidFill>
+            <a:srgbClr val="12294F"/>
+          </a:solidFill>
+          <a:ln/>
+        </p:spPr>
+        <p:txBody>
+          <a:bodyPr/>
+          <a:lstStyle/>
+          <a:p>
+            <a:endParaRPr lang="pt-BR"/>
+          </a:p>
+        </p:txBody>
+      </p:sp>
+      <p:sp>
+        <p:nvSpPr>
+          <p:cNvPr id="10" name="Text 7"/>
+          <p:cNvSpPr/>
+          <p:nvPr/>
+        </p:nvSpPr>
+        <p:spPr>
+          <a:xfrm>
+            <a:off x="3355848" y="3337560"/>
+            <a:ext cx="2606040" cy="548640"/>
+          </a:xfrm>
+          <a:prstGeom prst="rect">
+            <a:avLst/>
+          </a:prstGeom>
+          <a:noFill/>
+          <a:ln/>
+        </p:spPr>
+        <p:txBody>
+          <a:bodyPr wrap="square" rtlCol="0" anchor="ctr"/>
+          <a:lstStyle/>
+          <a:p>
+            <a:pPr marL="0" indent="0" algn="ctr">
+              <a:buNone/>
+            </a:pPr>
+            <a:r>
+              <a:rPr lang="pt-BR" sz="2000" b="1" dirty="0">
+                <a:solidFill>
+                  <a:srgbClr val="FFFFFF"/>
+                </a:solidFill>
+                <a:latin typeface="Arial" pitchFamily="34" charset="0"/>
+                <a:ea typeface="Arial" pitchFamily="34" charset="-122"/>
+                <a:cs typeface="Arial" pitchFamily="34" charset="-120"/>
+              </a:rPr>
+              <a:t>Claude</a:t>
+            </a:r>
+            <a:endParaRPr lang="en-US" sz="2600" dirty="0"/>
+          </a:p>
+        </p:txBody>
+      </p:sp>
+      <p:sp>
+        <p:nvSpPr>
+          <p:cNvPr id="11" name="Text 8"/>
+          <p:cNvSpPr/>
+          <p:nvPr/>
+        </p:nvSpPr>
+        <p:spPr>
+          <a:xfrm>
+            <a:off x="3493008" y="3931920"/>
+            <a:ext cx="2331720" cy="594360"/>
+          </a:xfrm>
+          <a:prstGeom prst="rect">
+            <a:avLst/>
+          </a:prstGeom>
+          <a:noFill/>
+          <a:ln/>
+        </p:spPr>
+        <p:txBody>
+          <a:bodyPr wrap="square" rtlCol="0" anchor="t"/>
+          <a:lstStyle/>
+          <a:p>
+            <a:pPr marL="0" indent="0" algn="ctr">
+              <a:buNone/>
+            </a:pPr>
+            <a:r>
+              <a:rPr lang="pt-BR" sz="1400" dirty="0">
+                <a:solidFill>
+                  <a:srgbClr val="D1D5DB"/>
+                </a:solidFill>
+                <a:latin typeface="Arial" pitchFamily="34" charset="0"/>
+                <a:ea typeface="Arial" pitchFamily="34" charset="-122"/>
+                <a:cs typeface="Arial" pitchFamily="34" charset="-120"/>
+              </a:rPr>
+              <a:t>Código e análises</a:t>
+            </a:r>
+            <a:br>
+              <a:rPr lang="pt-BR" sz="1300"/>
+            </a:br>
+            <a:r>
+              <a:rPr lang="pt-BR" sz="1300" dirty="0">
+                <a:solidFill>
+                  <a:srgbClr val="F28C2B"/>
+                </a:solidFill>
+                <a:latin typeface="Arial" pitchFamily="34" charset="0"/>
+                <a:cs typeface="Arial" pitchFamily="34" charset="-120"/>
+              </a:rPr>
+              <a:t>claude.ai</a:t>
+            </a:r>
+            <a:endParaRPr lang="en-US" sz="1600" dirty="0"/>
+          </a:p>
+        </p:txBody>
+      </p:sp>
+      <p:sp>
+        <p:nvSpPr>
+          <p:cNvPr id="12" name="Shape 9"/>
+          <p:cNvSpPr/>
+          <p:nvPr/>
+        </p:nvSpPr>
+        <p:spPr>
+          <a:xfrm>
+            <a:off x="6208776" y="3200400"/>
+            <a:ext cx="2606040" cy="1463040"/>
+          </a:xfrm>
+          <a:prstGeom prst="roundRect">
+            <a:avLst>
+              <a:gd name="adj" fmla="val 7500"/>
+            </a:avLst>
+          </a:prstGeom>
+          <a:solidFill>
+            <a:srgbClr val="12294F"/>
+          </a:solidFill>
+          <a:ln/>
+        </p:spPr>
+        <p:txBody>
+          <a:bodyPr/>
+          <a:lstStyle/>
+          <a:p>
+            <a:endParaRPr lang="pt-BR"/>
+          </a:p>
+        </p:txBody>
+      </p:sp>
+      <p:sp>
+        <p:nvSpPr>
+          <p:cNvPr id="13" name="Text 10"/>
+          <p:cNvSpPr/>
+          <p:nvPr/>
+        </p:nvSpPr>
+        <p:spPr>
+          <a:xfrm>
+            <a:off x="6208776" y="3337560"/>
+            <a:ext cx="2606040" cy="548640"/>
+          </a:xfrm>
+          <a:prstGeom prst="rect">
+            <a:avLst/>
+          </a:prstGeom>
+          <a:noFill/>
+          <a:ln/>
+        </p:spPr>
+        <p:txBody>
+          <a:bodyPr wrap="square" rtlCol="0" anchor="ctr"/>
+          <a:lstStyle/>
+          <a:p>
+            <a:pPr marL="0" indent="0" algn="ctr">
+              <a:buNone/>
+            </a:pPr>
+            <a:r>
+              <a:rPr lang="pt-BR" sz="2000" b="1" dirty="0">
+                <a:solidFill>
+                  <a:srgbClr val="FFFFFF"/>
+                </a:solidFill>
+                <a:latin typeface="Arial" pitchFamily="34" charset="0"/>
+                <a:ea typeface="Arial" pitchFamily="34" charset="-122"/>
+                <a:cs typeface="Arial" pitchFamily="34" charset="-120"/>
+              </a:rPr>
+              <a:t>Gemini</a:t>
+            </a:r>
+            <a:endParaRPr lang="en-US" sz="2600" dirty="0"/>
+          </a:p>
+        </p:txBody>
+      </p:sp>
+      <p:sp>
+        <p:nvSpPr>
+          <p:cNvPr id="14" name="Text 11"/>
+          <p:cNvSpPr/>
+          <p:nvPr/>
+        </p:nvSpPr>
+        <p:spPr>
+          <a:xfrm>
+            <a:off x="6345936" y="3931920"/>
+            <a:ext cx="2331720" cy="594360"/>
+          </a:xfrm>
+          <a:prstGeom prst="rect">
+            <a:avLst/>
+          </a:prstGeom>
+          <a:noFill/>
+          <a:ln/>
+        </p:spPr>
+        <p:txBody>
+          <a:bodyPr wrap="square" rtlCol="0" anchor="t"/>
+          <a:lstStyle/>
+          <a:p>
+            <a:pPr marL="0" indent="0" algn="ctr">
+              <a:buNone/>
+            </a:pPr>
+            <a:r>
+              <a:rPr lang="pt-BR" sz="1400" dirty="0">
+                <a:solidFill>
+                  <a:srgbClr val="D1D5DB"/>
+                </a:solidFill>
+                <a:latin typeface="Arial" pitchFamily="34" charset="0"/>
+                <a:ea typeface="Arial" pitchFamily="34" charset="-122"/>
+                <a:cs typeface="Arial" pitchFamily="34" charset="-120"/>
+              </a:rPr>
+              <a:t>Google · Gmail e Drive</a:t>
+            </a:r>
+            <a:br>
+              <a:rPr lang="pt-BR" sz="1300"/>
+            </a:br>
+            <a:r>
+              <a:rPr lang="pt-BR" sz="1300" dirty="0">
+                <a:solidFill>
+                  <a:srgbClr val="F28C2B"/>
+                </a:solidFill>
+                <a:latin typeface="Arial" pitchFamily="34" charset="0"/>
+                <a:cs typeface="Arial" pitchFamily="34" charset="-120"/>
+              </a:rPr>
+              <a:t>gemini.google.com</a:t>
+            </a:r>
+            <a:endParaRPr lang="en-US" sz="1600" dirty="0"/>
+          </a:p>
+        </p:txBody>
+      </p:sp>
+      <p:sp>
+        <p:nvSpPr>
+          <p:cNvPr id="15" name="Shape 12"/>
+          <p:cNvSpPr/>
+          <p:nvPr/>
+        </p:nvSpPr>
+        <p:spPr>
+          <a:xfrm>
+            <a:off x="9061704" y="3200400"/>
+            <a:ext cx="2606040" cy="1463040"/>
+          </a:xfrm>
+          <a:prstGeom prst="roundRect">
+            <a:avLst>
+              <a:gd name="adj" fmla="val 7500"/>
+            </a:avLst>
+          </a:prstGeom>
+          <a:solidFill>
+            <a:srgbClr val="12294F"/>
+          </a:solidFill>
+          <a:ln/>
+        </p:spPr>
+        <p:txBody>
+          <a:bodyPr/>
+          <a:lstStyle/>
+          <a:p>
+            <a:endParaRPr lang="pt-BR"/>
+          </a:p>
+        </p:txBody>
+      </p:sp>
+      <p:sp>
+        <p:nvSpPr>
+          <p:cNvPr id="16" name="Text 13"/>
+          <p:cNvSpPr/>
+          <p:nvPr/>
+        </p:nvSpPr>
+        <p:spPr>
+          <a:xfrm>
+            <a:off x="9061704" y="3337560"/>
+            <a:ext cx="2606040" cy="548640"/>
+          </a:xfrm>
+          <a:prstGeom prst="rect">
+            <a:avLst/>
+          </a:prstGeom>
+          <a:noFill/>
+          <a:ln/>
+        </p:spPr>
+        <p:txBody>
+          <a:bodyPr wrap="square" rtlCol="0" anchor="ctr"/>
+          <a:lstStyle/>
+          <a:p>
+            <a:pPr marL="0" indent="0" algn="ctr">
+              <a:buNone/>
+            </a:pPr>
+            <a:r>
+              <a:rPr lang="pt-BR" sz="2000" b="1" dirty="0">
+                <a:solidFill>
+                  <a:srgbClr val="FFFFFF"/>
+                </a:solidFill>
+                <a:latin typeface="Arial" pitchFamily="34" charset="0"/>
+                <a:ea typeface="Arial" pitchFamily="34" charset="-122"/>
+                <a:cs typeface="Arial" pitchFamily="34" charset="-120"/>
+              </a:rPr>
+              <a:t>Microsoft Copilot</a:t>
+            </a:r>
+            <a:endParaRPr lang="en-US" sz="2600" dirty="0"/>
+          </a:p>
+        </p:txBody>
+      </p:sp>
+      <p:sp>
+        <p:nvSpPr>
+          <p:cNvPr id="17" name="Text 14"/>
+          <p:cNvSpPr/>
+          <p:nvPr/>
+        </p:nvSpPr>
+        <p:spPr>
+          <a:xfrm>
+            <a:off x="9198864" y="3931920"/>
+            <a:ext cx="2331720" cy="594360"/>
+          </a:xfrm>
+          <a:prstGeom prst="rect">
+            <a:avLst/>
+          </a:prstGeom>
+          <a:noFill/>
+          <a:ln/>
+        </p:spPr>
+        <p:txBody>
+          <a:bodyPr wrap="square" rtlCol="0" anchor="t"/>
+          <a:lstStyle/>
+          <a:p>
+            <a:pPr marL="0" indent="0" algn="ctr">
+              <a:buNone/>
+            </a:pPr>
+            <a:r>
+              <a:rPr lang="pt-BR" sz="1400" dirty="0">
+                <a:solidFill>
+                  <a:srgbClr val="D1D5DB"/>
+                </a:solidFill>
+                <a:latin typeface="Arial" pitchFamily="34" charset="0"/>
+                <a:ea typeface="Arial" pitchFamily="34" charset="-122"/>
+                <a:cs typeface="Arial" pitchFamily="34" charset="-120"/>
+              </a:rPr>
+              <a:t>No Windows e no Edge</a:t>
+            </a:r>
+            <a:br>
+              <a:rPr lang="pt-BR" sz="1300"/>
+            </a:br>
+            <a:r>
+              <a:rPr lang="pt-BR" sz="1300" dirty="0">
+                <a:solidFill>
+                  <a:srgbClr val="F28C2B"/>
+                </a:solidFill>
+                <a:latin typeface="Arial" pitchFamily="34" charset="0"/>
+                <a:cs typeface="Arial" pitchFamily="34" charset="-120"/>
+              </a:rPr>
+              <a:t>copilot.microsoft.com</a:t>
+            </a:r>
+            <a:endParaRPr lang="en-US" sz="1600" dirty="0"/>
+          </a:p>
+        </p:txBody>
+      </p:sp>
+      <p:sp>
+        <p:nvSpPr>
+          <p:cNvPr id="18" name="Shape 15"/>
+          <p:cNvSpPr/>
+          <p:nvPr/>
+        </p:nvSpPr>
+        <p:spPr>
+          <a:xfrm>
+            <a:off x="502920" y="4846320"/>
+            <a:ext cx="2606040" cy="1463040"/>
+          </a:xfrm>
+          <a:prstGeom prst="roundRect">
+            <a:avLst>
+              <a:gd name="adj" fmla="val 7500"/>
+            </a:avLst>
+          </a:prstGeom>
+          <a:solidFill>
+            <a:srgbClr val="12294F"/>
+          </a:solidFill>
+          <a:ln/>
+        </p:spPr>
+        <p:txBody>
+          <a:bodyPr/>
+          <a:lstStyle/>
+          <a:p>
+            <a:endParaRPr lang="pt-BR"/>
+          </a:p>
+        </p:txBody>
+      </p:sp>
+      <p:sp>
+        <p:nvSpPr>
+          <p:cNvPr id="19" name="Text 16"/>
+          <p:cNvSpPr/>
+          <p:nvPr/>
+        </p:nvSpPr>
+        <p:spPr>
+          <a:xfrm>
+            <a:off x="502920" y="4983480"/>
+            <a:ext cx="2606040" cy="548640"/>
+          </a:xfrm>
+          <a:prstGeom prst="rect">
+            <a:avLst/>
+          </a:prstGeom>
+          <a:noFill/>
+          <a:ln/>
+        </p:spPr>
+        <p:txBody>
+          <a:bodyPr wrap="square" rtlCol="0" anchor="ctr"/>
+          <a:lstStyle/>
+          <a:p>
+            <a:pPr marL="0" indent="0" algn="ctr">
+              <a:buNone/>
+            </a:pPr>
+            <a:r>
+              <a:rPr lang="pt-BR" sz="2000" b="1" dirty="0">
+                <a:solidFill>
+                  <a:srgbClr val="FFFFFF"/>
+                </a:solidFill>
+                <a:latin typeface="Arial" pitchFamily="34" charset="0"/>
+                <a:ea typeface="Arial" pitchFamily="34" charset="-122"/>
+                <a:cs typeface="Arial" pitchFamily="34" charset="-120"/>
+              </a:rPr>
+              <a:t>GitHub Copilot</a:t>
+            </a:r>
+            <a:endParaRPr lang="en-US" sz="2600" dirty="0"/>
+          </a:p>
+        </p:txBody>
+      </p:sp>
+      <p:sp>
+        <p:nvSpPr>
+          <p:cNvPr id="20" name="Text 17"/>
+          <p:cNvSpPr/>
+          <p:nvPr/>
+        </p:nvSpPr>
+        <p:spPr>
+          <a:xfrm>
+            <a:off x="640080" y="5577840"/>
+            <a:ext cx="2331720" cy="594360"/>
+          </a:xfrm>
+          <a:prstGeom prst="rect">
+            <a:avLst/>
+          </a:prstGeom>
+          <a:noFill/>
+          <a:ln/>
+        </p:spPr>
+        <p:txBody>
+          <a:bodyPr wrap="square" rtlCol="0" anchor="t"/>
+          <a:lstStyle/>
+          <a:p>
+            <a:pPr marL="0" indent="0" algn="ctr">
+              <a:buNone/>
+            </a:pPr>
+            <a:r>
+              <a:rPr lang="pt-BR" sz="1400" dirty="0">
+                <a:solidFill>
+                  <a:srgbClr val="D1D5DB"/>
+                </a:solidFill>
+                <a:latin typeface="Arial" pitchFamily="34" charset="0"/>
+                <a:ea typeface="Arial" pitchFamily="34" charset="-122"/>
+                <a:cs typeface="Arial" pitchFamily="34" charset="-120"/>
+              </a:rPr>
+              <a:t>Programa no VS Code</a:t>
+            </a:r>
+            <a:br>
+              <a:rPr lang="pt-BR" sz="1300"/>
+            </a:br>
+            <a:r>
+              <a:rPr lang="pt-BR" sz="1300" dirty="0">
+                <a:solidFill>
+                  <a:srgbClr val="F28C2B"/>
+                </a:solidFill>
+                <a:latin typeface="Arial" pitchFamily="34" charset="0"/>
+                <a:cs typeface="Arial" pitchFamily="34" charset="-120"/>
+              </a:rPr>
+              <a:t>plano gratuito</a:t>
+            </a:r>
+            <a:endParaRPr lang="en-US" sz="1600" dirty="0"/>
+          </a:p>
+        </p:txBody>
+      </p:sp>
+      <p:sp>
+        <p:nvSpPr>
+          <p:cNvPr id="21" name="Shape 18"/>
+          <p:cNvSpPr/>
+          <p:nvPr/>
+        </p:nvSpPr>
+        <p:spPr>
+          <a:xfrm>
+            <a:off x="3355848" y="4846320"/>
+            <a:ext cx="2606040" cy="1463040"/>
+          </a:xfrm>
+          <a:prstGeom prst="roundRect">
+            <a:avLst>
+              <a:gd name="adj" fmla="val 7500"/>
+            </a:avLst>
+          </a:prstGeom>
+          <a:solidFill>
+            <a:srgbClr val="12294F"/>
+          </a:solidFill>
+          <a:ln/>
+        </p:spPr>
+        <p:txBody>
+          <a:bodyPr/>
+          <a:lstStyle/>
+          <a:p>
+            <a:endParaRPr lang="pt-BR"/>
+          </a:p>
+        </p:txBody>
+      </p:sp>
+      <p:sp>
+        <p:nvSpPr>
+          <p:cNvPr id="22" name="Text 19"/>
+          <p:cNvSpPr/>
+          <p:nvPr/>
+        </p:nvSpPr>
+        <p:spPr>
+          <a:xfrm>
+            <a:off x="3355848" y="4983480"/>
+            <a:ext cx="2606040" cy="548640"/>
+          </a:xfrm>
+          <a:prstGeom prst="rect">
+            <a:avLst/>
+          </a:prstGeom>
+          <a:noFill/>
+          <a:ln/>
+        </p:spPr>
+        <p:txBody>
+          <a:bodyPr wrap="square" rtlCol="0" anchor="ctr"/>
+          <a:lstStyle/>
+          <a:p>
+            <a:pPr marL="0" indent="0" algn="ctr">
+              <a:buNone/>
+            </a:pPr>
+            <a:r>
+              <a:rPr lang="pt-BR" sz="2000" b="1" dirty="0">
+                <a:solidFill>
+                  <a:srgbClr val="FFFFFF"/>
+                </a:solidFill>
+                <a:latin typeface="Arial" pitchFamily="34" charset="0"/>
+                <a:ea typeface="Arial" pitchFamily="34" charset="-122"/>
+                <a:cs typeface="Arial" pitchFamily="34" charset="-120"/>
+              </a:rPr>
+              <a:t>Perplexity</a:t>
+            </a:r>
+            <a:endParaRPr lang="en-US" sz="2600" dirty="0"/>
+          </a:p>
+        </p:txBody>
+      </p:sp>
+      <p:sp>
+        <p:nvSpPr>
+          <p:cNvPr id="23" name="Text 20"/>
+          <p:cNvSpPr/>
+          <p:nvPr/>
+        </p:nvSpPr>
+        <p:spPr>
+          <a:xfrm>
+            <a:off x="3493008" y="5577840"/>
+            <a:ext cx="2331720" cy="594360"/>
+          </a:xfrm>
+          <a:prstGeom prst="rect">
+            <a:avLst/>
+          </a:prstGeom>
+          <a:noFill/>
+          <a:ln/>
+        </p:spPr>
+        <p:txBody>
+          <a:bodyPr wrap="square" rtlCol="0" anchor="t"/>
+          <a:lstStyle/>
+          <a:p>
+            <a:pPr marL="0" indent="0" algn="ctr">
+              <a:buNone/>
+            </a:pPr>
+            <a:r>
+              <a:rPr lang="pt-BR" sz="1400" dirty="0">
+                <a:solidFill>
+                  <a:srgbClr val="D1D5DB"/>
+                </a:solidFill>
+                <a:latin typeface="Arial" pitchFamily="34" charset="0"/>
+                <a:ea typeface="Arial" pitchFamily="34" charset="-122"/>
+                <a:cs typeface="Arial" pitchFamily="34" charset="-120"/>
+              </a:rPr>
+              <a:t>Pesquisa com fontes</a:t>
+            </a:r>
+            <a:br>
+              <a:rPr lang="pt-BR" sz="1300"/>
+            </a:br>
+            <a:r>
+              <a:rPr lang="pt-BR" sz="1300" dirty="0">
+                <a:solidFill>
+                  <a:srgbClr val="F28C2B"/>
+                </a:solidFill>
+                <a:latin typeface="Arial" pitchFamily="34" charset="0"/>
+                <a:cs typeface="Arial" pitchFamily="34" charset="-120"/>
+              </a:rPr>
+              <a:t>perplexity.ai</a:t>
+            </a:r>
+            <a:endParaRPr lang="en-US" sz="1600" dirty="0"/>
+          </a:p>
+        </p:txBody>
+      </p:sp>
+      <p:sp>
+        <p:nvSpPr>
+          <p:cNvPr id="24" name="Shape 21"/>
+          <p:cNvSpPr/>
+          <p:nvPr/>
+        </p:nvSpPr>
+        <p:spPr>
+          <a:xfrm>
+            <a:off x="6208776" y="4846320"/>
+            <a:ext cx="2606040" cy="1463040"/>
+          </a:xfrm>
+          <a:prstGeom prst="roundRect">
+            <a:avLst>
+              <a:gd name="adj" fmla="val 7500"/>
+            </a:avLst>
+          </a:prstGeom>
+          <a:solidFill>
+            <a:srgbClr val="12294F"/>
+          </a:solidFill>
+          <a:ln/>
+        </p:spPr>
+        <p:txBody>
+          <a:bodyPr/>
+          <a:lstStyle/>
+          <a:p>
+            <a:endParaRPr lang="pt-BR"/>
+          </a:p>
+        </p:txBody>
+      </p:sp>
+      <p:sp>
+        <p:nvSpPr>
+          <p:cNvPr id="25" name="Text 22"/>
+          <p:cNvSpPr/>
+          <p:nvPr/>
+        </p:nvSpPr>
+        <p:spPr>
+          <a:xfrm>
+            <a:off x="6208776" y="4983480"/>
+            <a:ext cx="2606040" cy="548640"/>
+          </a:xfrm>
+          <a:prstGeom prst="rect">
+            <a:avLst/>
+          </a:prstGeom>
+          <a:noFill/>
+          <a:ln/>
+        </p:spPr>
+        <p:txBody>
+          <a:bodyPr wrap="square" rtlCol="0" anchor="ctr"/>
+          <a:lstStyle/>
+          <a:p>
+            <a:pPr marL="0" indent="0" algn="ctr">
+              <a:buNone/>
+            </a:pPr>
+            <a:r>
+              <a:rPr lang="pt-BR" sz="2000" b="1" dirty="0">
+                <a:solidFill>
+                  <a:srgbClr val="FFFFFF"/>
+                </a:solidFill>
+                <a:latin typeface="Arial" pitchFamily="34" charset="0"/>
+                <a:ea typeface="Arial" pitchFamily="34" charset="-122"/>
+                <a:cs typeface="Arial" pitchFamily="34" charset="-120"/>
+              </a:rPr>
+              <a:t>NotebookLM</a:t>
+            </a:r>
+            <a:endParaRPr lang="en-US" sz="2600" dirty="0"/>
+          </a:p>
+        </p:txBody>
+      </p:sp>
+      <p:sp>
+        <p:nvSpPr>
+          <p:cNvPr id="26" name="Text 23"/>
+          <p:cNvSpPr/>
+          <p:nvPr/>
+        </p:nvSpPr>
+        <p:spPr>
+          <a:xfrm>
+            <a:off x="6345936" y="5577840"/>
+            <a:ext cx="2331720" cy="594360"/>
+          </a:xfrm>
+          <a:prstGeom prst="rect">
+            <a:avLst/>
+          </a:prstGeom>
+          <a:noFill/>
+          <a:ln/>
+        </p:spPr>
+        <p:txBody>
+          <a:bodyPr wrap="square" rtlCol="0" anchor="t"/>
+          <a:lstStyle/>
+          <a:p>
+            <a:pPr marL="0" indent="0" algn="ctr">
+              <a:buNone/>
+            </a:pPr>
+            <a:r>
+              <a:rPr lang="pt-BR" sz="1400" dirty="0">
+                <a:solidFill>
+                  <a:srgbClr val="D1D5DB"/>
+                </a:solidFill>
+                <a:latin typeface="Arial" pitchFamily="34" charset="0"/>
+                <a:ea typeface="Arial" pitchFamily="34" charset="-122"/>
+                <a:cs typeface="Arial" pitchFamily="34" charset="-120"/>
+              </a:rPr>
+              <a:t>Estuda seus PDFs</a:t>
+            </a:r>
+            <a:br>
+              <a:rPr lang="pt-BR" sz="1300"/>
+            </a:br>
+            <a:r>
+              <a:rPr lang="pt-BR" sz="1300" dirty="0">
+                <a:solidFill>
+                  <a:srgbClr val="F28C2B"/>
+                </a:solidFill>
+                <a:latin typeface="Arial" pitchFamily="34" charset="0"/>
+                <a:cs typeface="Arial" pitchFamily="34" charset="-120"/>
+              </a:rPr>
+              <a:t>notebooklm.google.com</a:t>
+            </a:r>
+            <a:endParaRPr lang="en-US" sz="1600" dirty="0"/>
+          </a:p>
+        </p:txBody>
+      </p:sp>
+      <p:sp>
+        <p:nvSpPr>
+          <p:cNvPr id="27" name="Shape 24"/>
+          <p:cNvSpPr/>
+          <p:nvPr/>
+        </p:nvSpPr>
+        <p:spPr>
+          <a:xfrm>
+            <a:off x="9061704" y="4846320"/>
+            <a:ext cx="2606040" cy="1463040"/>
+          </a:xfrm>
+          <a:prstGeom prst="roundRect">
+            <a:avLst>
+              <a:gd name="adj" fmla="val 7500"/>
+            </a:avLst>
+          </a:prstGeom>
+          <a:solidFill>
+            <a:srgbClr val="12294F"/>
+          </a:solidFill>
+          <a:ln/>
+        </p:spPr>
+        <p:txBody>
+          <a:bodyPr/>
+          <a:lstStyle/>
+          <a:p>
+            <a:endParaRPr lang="pt-BR"/>
+          </a:p>
+        </p:txBody>
+      </p:sp>
+      <p:sp>
+        <p:nvSpPr>
+          <p:cNvPr id="28" name="Text 25"/>
+          <p:cNvSpPr/>
+          <p:nvPr/>
+        </p:nvSpPr>
+        <p:spPr>
+          <a:xfrm>
+            <a:off x="9061704" y="4983480"/>
+            <a:ext cx="2606040" cy="548640"/>
+          </a:xfrm>
+          <a:prstGeom prst="rect">
+            <a:avLst/>
+          </a:prstGeom>
+          <a:noFill/>
+          <a:ln/>
+        </p:spPr>
+        <p:txBody>
+          <a:bodyPr wrap="square" rtlCol="0" anchor="ctr"/>
+          <a:lstStyle/>
+          <a:p>
+            <a:pPr marL="0" indent="0" algn="ctr">
+              <a:buNone/>
+            </a:pPr>
+            <a:r>
+              <a:rPr lang="pt-BR" sz="2000" b="1" dirty="0">
+                <a:solidFill>
+                  <a:srgbClr val="FFFFFF"/>
+                </a:solidFill>
+                <a:latin typeface="Arial" pitchFamily="34" charset="0"/>
+                <a:ea typeface="Arial" pitchFamily="34" charset="-122"/>
+                <a:cs typeface="Arial" pitchFamily="34" charset="-120"/>
+              </a:rPr>
+              <a:t>Meta AI</a:t>
+            </a:r>
+            <a:endParaRPr lang="en-US" sz="2600" dirty="0"/>
+          </a:p>
+        </p:txBody>
+      </p:sp>
+      <p:sp>
+        <p:nvSpPr>
+          <p:cNvPr id="29" name="Text 26"/>
+          <p:cNvSpPr/>
+          <p:nvPr/>
+        </p:nvSpPr>
+        <p:spPr>
+          <a:xfrm>
+            <a:off x="9198864" y="5577840"/>
+            <a:ext cx="2331720" cy="594360"/>
+          </a:xfrm>
+          <a:prstGeom prst="rect">
+            <a:avLst/>
+          </a:prstGeom>
+          <a:noFill/>
+          <a:ln/>
+        </p:spPr>
+        <p:txBody>
+          <a:bodyPr wrap="square" rtlCol="0" anchor="t"/>
+          <a:lstStyle/>
+          <a:p>
+            <a:pPr marL="0" indent="0" algn="ctr">
+              <a:buNone/>
+            </a:pPr>
+            <a:r>
+              <a:rPr lang="pt-BR" sz="1400" dirty="0">
+                <a:solidFill>
+                  <a:srgbClr val="D1D5DB"/>
+                </a:solidFill>
+                <a:latin typeface="Arial" pitchFamily="34" charset="0"/>
+                <a:ea typeface="Arial" pitchFamily="34" charset="-122"/>
+                <a:cs typeface="Arial" pitchFamily="34" charset="-120"/>
+              </a:rPr>
+              <a:t>Dentro do WhatsApp</a:t>
+            </a:r>
+            <a:br>
+              <a:rPr lang="pt-BR" sz="1300"/>
+            </a:br>
+            <a:r>
+              <a:rPr lang="pt-BR" sz="1300" dirty="0">
+                <a:solidFill>
+                  <a:srgbClr val="F28C2B"/>
+                </a:solidFill>
+                <a:latin typeface="Arial" pitchFamily="34" charset="0"/>
+                <a:cs typeface="Arial" pitchFamily="34" charset="-120"/>
+              </a:rPr>
+              <a:t>meta.ai</a:t>
+            </a:r>
+            <a:endParaRPr lang="en-US" sz="1600" dirty="0"/>
+          </a:p>
+        </p:txBody>
+      </p:sp>
+    </p:spTree>
+  </p:cSld>
+  <p:clrMapOvr>
+    <a:masterClrMapping/>
+  </p:clrMapOvr>
+</p:sld>
+</file>
+
+<file path=ppt/slides/slide8.xml><?xml version="1.0" encoding="utf-8"?>
 <p:sld xmlns:a="http://schemas.openxmlformats.org/drawingml/2006/main" xmlns:r="http://schemas.openxmlformats.org/officeDocument/2006/relationships" xmlns:p="http://schemas.openxmlformats.org/presentationml/2006/main">
   <p:cSld name="Slide 7">
     <p:bg>
@@ -9190,7 +11200,7 @@
                 <a:ea typeface="Arial" pitchFamily="34" charset="-122"/>
                 <a:cs typeface="Arial" pitchFamily="34" charset="-120"/>
               </a:rPr>
-              <a:t>07</a:t>
+              <a:t>08</a:t>
             </a:r>
             <a:endParaRPr lang="en-US" sz="1600" dirty="0"/>
           </a:p>
@@ -9302,7 +11312,7 @@
                 <a:ea typeface="Courier New" pitchFamily="34" charset="-122"/>
                 <a:cs typeface="Courier New" pitchFamily="34" charset="-120"/>
               </a:rPr>
-              <a:t>$ python robo_selic.py</a:t>
+              <a:t>$ RoboSelic.exe      (ou: python main.py)</a:t>
             </a:r>
             <a:endParaRPr lang="en-US" sz="1500" dirty="0"/>
           </a:p>
@@ -9341,7 +11351,7 @@
                 <a:ea typeface="Courier New" pitchFamily="34" charset="-122"/>
                 <a:cs typeface="Courier New" pitchFamily="34" charset="-120"/>
               </a:rPr>
-              <a:t>Consultando Banco Central...</a:t>
+              <a:t>Consultando a API do Banco Central (série 1178)...</a:t>
             </a:r>
             <a:endParaRPr lang="en-US" sz="1500" dirty="0"/>
           </a:p>
@@ -9380,7 +11390,7 @@
                 <a:ea typeface="Courier New" pitchFamily="34" charset="-122"/>
                 <a:cs typeface="Courier New" pitchFamily="34" charset="-120"/>
               </a:rPr>
-              <a:t>✔ Dados obtidos com sucesso!</a:t>
+              <a:t>✔ Dados obtidos com sucesso: 30 registros.</a:t>
             </a:r>
             <a:endParaRPr lang="en-US" sz="1500" dirty="0"/>
           </a:p>
@@ -9419,7 +11429,7 @@
                 <a:ea typeface="Courier New" pitchFamily="34" charset="-122"/>
                 <a:cs typeface="Courier New" pitchFamily="34" charset="-120"/>
               </a:rPr>
-              <a:t>Período: 21/05/2026 a 19/06/2026</a:t>
+              <a:t>Período: 12/08/2026 a 23/09/2026</a:t>
             </a:r>
             <a:endParaRPr lang="en-US" sz="1500" dirty="0"/>
           </a:p>
@@ -9458,7 +11468,7 @@
                 <a:ea typeface="Courier New" pitchFamily="34" charset="-122"/>
                 <a:cs typeface="Courier New" pitchFamily="34" charset="-120"/>
               </a:rPr>
-              <a:t>Registros: 30</a:t>
+              <a:t>Último valor: 13,65% | Variação: -0,25 p.p.</a:t>
             </a:r>
             <a:endParaRPr lang="en-US" sz="1500" dirty="0"/>
           </a:p>
@@ -9525,7 +11535,7 @@
                 <a:ea typeface="Courier New" pitchFamily="34" charset="-122"/>
                 <a:cs typeface="Courier New" pitchFamily="34" charset="-120"/>
               </a:rPr>
-              <a:t>Arquivo gerado: SELIC_Ultimos_30_dias.xlsx</a:t>
+              <a:t>Excel:   output\selic.xlsx</a:t>
             </a:r>
             <a:endParaRPr lang="en-US" sz="1500" dirty="0"/>
           </a:p>
@@ -9564,7 +11574,7 @@
                 <a:ea typeface="Courier New" pitchFamily="34" charset="-122"/>
                 <a:cs typeface="Courier New" pitchFamily="34" charset="-120"/>
               </a:rPr>
-              <a:t>Gráfico: selic_30_dias.png</a:t>
+              <a:t>Gráfico: output\selic.png  |  PDF: resumo_selic.pdf</a:t>
             </a:r>
             <a:endParaRPr lang="en-US" sz="1500" dirty="0"/>
           </a:p>
@@ -9631,7 +11641,7 @@
                 <a:ea typeface="Courier New" pitchFamily="34" charset="-122"/>
                 <a:cs typeface="Courier New" pitchFamily="34" charset="-120"/>
               </a:rPr>
-              <a:t>Resumo executivo exibido abaixo</a:t>
+              <a:t>Processo concluído com sucesso.</a:t>
             </a:r>
             <a:endParaRPr lang="en-US" sz="1500" dirty="0"/>
           </a:p>
@@ -9805,7 +11815,7 @@
 </p:sld>
 </file>
 
-<file path=ppt/slides/slide8.xml><?xml version="1.0" encoding="utf-8"?>
+<file path=ppt/slides/slide9.xml><?xml version="1.0" encoding="utf-8"?>
 <p:sld xmlns:a="http://schemas.openxmlformats.org/drawingml/2006/main" xmlns:r="http://schemas.openxmlformats.org/officeDocument/2006/relationships" xmlns:p="http://schemas.openxmlformats.org/presentationml/2006/main">
   <p:cSld name="Slide 8">
     <p:bg>
@@ -9887,7 +11897,7 @@
                 <a:ea typeface="Arial" pitchFamily="34" charset="-122"/>
                 <a:cs typeface="Arial" pitchFamily="34" charset="-120"/>
               </a:rPr>
-              <a:t>08</a:t>
+              <a:t>09</a:t>
             </a:r>
             <a:endParaRPr lang="en-US" sz="1600" dirty="0"/>
           </a:p>
@@ -9967,7 +11977,7 @@
                 <a:ea typeface="Arial" pitchFamily="34" charset="-122"/>
                 <a:cs typeface="Arial" pitchFamily="34" charset="-120"/>
               </a:rPr>
-              <a:t>SELIC – Últimos 30 dias</a:t>
+              <a:t>SELIC – Últimas 30 observações</a:t>
             </a:r>
             <a:endParaRPr lang="en-US" sz="1600" dirty="0"/>
           </a:p>
@@ -10172,7 +12182,7 @@
                           <a:ea typeface="Arial" pitchFamily="34" charset="-122"/>
                           <a:cs typeface="Arial" pitchFamily="34" charset="-120"/>
                         </a:rPr>
-                        <a:t>19/06/2026</a:t>
+                        <a:t>23/09/2026</a:t>
                       </a:r>
                       <a:endParaRPr lang="en-US" sz="1500" dirty="0">
                         <a:latin typeface="Arial" charset="0"/>
@@ -10240,7 +12250,7 @@
                           <a:ea typeface="Arial" pitchFamily="34" charset="-122"/>
                           <a:cs typeface="Arial" pitchFamily="34" charset="-120"/>
                         </a:rPr>
-                        <a:t>14,75</a:t>
+                        <a:t>13,65</a:t>
                       </a:r>
                       <a:endParaRPr lang="en-US" sz="1500" dirty="0">
                         <a:latin typeface="Arial" charset="0"/>
@@ -10315,7 +12325,7 @@
                           <a:ea typeface="Arial" pitchFamily="34" charset="-122"/>
                           <a:cs typeface="Arial" pitchFamily="34" charset="-120"/>
                         </a:rPr>
-                        <a:t>18/06/2026</a:t>
+                        <a:t>22/09/2026</a:t>
                       </a:r>
                       <a:endParaRPr lang="en-US" sz="1500" dirty="0">
                         <a:latin typeface="Arial" charset="0"/>
@@ -10383,7 +12393,7 @@
                           <a:ea typeface="Arial" pitchFamily="34" charset="-122"/>
                           <a:cs typeface="Arial" pitchFamily="34" charset="-120"/>
                         </a:rPr>
-                        <a:t>14,75</a:t>
+                        <a:t>13,65</a:t>
                       </a:r>
                       <a:endParaRPr lang="en-US" sz="1500" dirty="0">
                         <a:latin typeface="Arial" charset="0"/>
@@ -10458,7 +12468,7 @@
                           <a:ea typeface="Arial" pitchFamily="34" charset="-122"/>
                           <a:cs typeface="Arial" pitchFamily="34" charset="-120"/>
                         </a:rPr>
-                        <a:t>17/06/2026</a:t>
+                        <a:t>21/09/2026</a:t>
                       </a:r>
                       <a:endParaRPr lang="en-US" sz="1500" dirty="0">
                         <a:latin typeface="Arial" charset="0"/>
@@ -10526,7 +12536,7 @@
                           <a:ea typeface="Arial" pitchFamily="34" charset="-122"/>
                           <a:cs typeface="Arial" pitchFamily="34" charset="-120"/>
                         </a:rPr>
-                        <a:t>14,75</a:t>
+                        <a:t>13,65</a:t>
                       </a:r>
                       <a:endParaRPr lang="en-US" sz="1500" dirty="0">
                         <a:latin typeface="Arial" charset="0"/>
@@ -10601,7 +12611,7 @@
                           <a:ea typeface="Arial" pitchFamily="34" charset="-122"/>
                           <a:cs typeface="Arial" pitchFamily="34" charset="-120"/>
                         </a:rPr>
-                        <a:t>16/06/2026</a:t>
+                        <a:t>18/09/2026</a:t>
                       </a:r>
                       <a:endParaRPr lang="en-US" sz="1500" dirty="0">
                         <a:latin typeface="Arial" charset="0"/>
@@ -10669,7 +12679,7 @@
                           <a:ea typeface="Arial" pitchFamily="34" charset="-122"/>
                           <a:cs typeface="Arial" pitchFamily="34" charset="-120"/>
                         </a:rPr>
-                        <a:t>14,75</a:t>
+                        <a:t>13,65</a:t>
                       </a:r>
                       <a:endParaRPr lang="en-US" sz="1500" dirty="0">
                         <a:latin typeface="Arial" charset="0"/>
@@ -10744,7 +12754,7 @@
                           <a:ea typeface="Arial" pitchFamily="34" charset="-122"/>
                           <a:cs typeface="Arial" pitchFamily="34" charset="-120"/>
                         </a:rPr>
-                        <a:t>13/06/2026</a:t>
+                        <a:t>17/09/2026</a:t>
                       </a:r>
                       <a:endParaRPr lang="en-US" sz="1500" dirty="0">
                         <a:latin typeface="Arial" charset="0"/>
@@ -10812,7 +12822,7 @@
                           <a:ea typeface="Arial" pitchFamily="34" charset="-122"/>
                           <a:cs typeface="Arial" pitchFamily="34" charset="-120"/>
                         </a:rPr>
-                        <a:t>14,75</a:t>
+                        <a:t>13,65</a:t>
                       </a:r>
                       <a:endParaRPr lang="en-US" sz="1500" dirty="0">
                         <a:latin typeface="Arial" charset="0"/>
@@ -10887,7 +12897,7 @@
                           <a:ea typeface="Arial" pitchFamily="34" charset="-122"/>
                           <a:cs typeface="Arial" pitchFamily="34" charset="-120"/>
                         </a:rPr>
-                        <a:t>12/06/2026</a:t>
+                        <a:t>16/09/2026</a:t>
                       </a:r>
                       <a:endParaRPr lang="en-US" sz="1500" dirty="0">
                         <a:latin typeface="Arial" charset="0"/>
@@ -10955,7 +12965,7 @@
                           <a:ea typeface="Arial" pitchFamily="34" charset="-122"/>
                           <a:cs typeface="Arial" pitchFamily="34" charset="-120"/>
                         </a:rPr>
-                        <a:t>14,75</a:t>
+                        <a:t>13,90</a:t>
                       </a:r>
                       <a:endParaRPr lang="en-US" sz="1500" dirty="0">
                         <a:latin typeface="Arial" charset="0"/>
@@ -11030,7 +13040,7 @@
                           <a:ea typeface="Arial" pitchFamily="34" charset="-122"/>
                           <a:cs typeface="Arial" pitchFamily="34" charset="-120"/>
                         </a:rPr>
-                        <a:t>21/05/2026</a:t>
+                        <a:t>12/08/2026</a:t>
                       </a:r>
                       <a:endParaRPr lang="en-US" sz="1500" dirty="0">
                         <a:latin typeface="Arial" charset="0"/>
@@ -11098,7 +13108,7 @@
                           <a:ea typeface="Arial" pitchFamily="34" charset="-122"/>
                           <a:cs typeface="Arial" pitchFamily="34" charset="-120"/>
                         </a:rPr>
-                        <a:t>14,50</a:t>
+                        <a:t>13,90</a:t>
                       </a:r>
                       <a:endParaRPr lang="en-US" sz="1500" dirty="0">
                         <a:latin typeface="Arial" charset="0"/>
@@ -11209,7 +13219,7 @@
                 <a:ea typeface="Arial" pitchFamily="34" charset="-122"/>
                 <a:cs typeface="Arial" pitchFamily="34" charset="-120"/>
               </a:rPr>
-              <a:t>Últimos 30 dias</a:t>
+              <a:t>Últimas 30 observações</a:t>
             </a:r>
             <a:endParaRPr lang="en-US" sz="1600" dirty="0"/>
           </a:p>
@@ -11231,878 +13241,6 @@
           </a:graphicData>
         </a:graphic>
       </p:graphicFrame>
-    </p:spTree>
-  </p:cSld>
-  <p:clrMapOvr>
-    <a:masterClrMapping/>
-  </p:clrMapOvr>
-</p:sld>
-</file>
-
-<file path=ppt/slides/slide9.xml><?xml version="1.0" encoding="utf-8"?>
-<p:sld xmlns:a="http://schemas.openxmlformats.org/drawingml/2006/main" xmlns:r="http://schemas.openxmlformats.org/officeDocument/2006/relationships" xmlns:p="http://schemas.openxmlformats.org/presentationml/2006/main">
-  <p:cSld name="Slide 9">
-    <p:bg>
-      <p:bgPr>
-        <a:solidFill>
-          <a:srgbClr val="0B1D3A"/>
-        </a:solidFill>
-        <a:effectLst/>
-      </p:bgPr>
-    </p:bg>
-    <p:spTree>
-      <p:nvGrpSpPr>
-        <p:cNvPr id="1" name=""/>
-        <p:cNvGrpSpPr/>
-        <p:nvPr/>
-      </p:nvGrpSpPr>
-      <p:grpSpPr>
-        <a:xfrm>
-          <a:off x="0" y="0"/>
-          <a:ext cx="0" cy="0"/>
-          <a:chOff x="0" y="0"/>
-          <a:chExt cx="0" cy="0"/>
-        </a:xfrm>
-      </p:grpSpPr>
-      <p:pic>
-        <p:nvPicPr>
-          <p:cNvPr id="2" name="Image 0" descr="preencoded.png"/>
-          <p:cNvPicPr>
-            <a:picLocks noChangeAspect="1"/>
-          </p:cNvPicPr>
-          <p:nvPr/>
-        </p:nvPicPr>
-        <p:blipFill>
-          <a:blip r:embed="rId3"/>
-          <a:stretch>
-            <a:fillRect/>
-          </a:stretch>
-        </p:blipFill>
-        <p:spPr>
-          <a:xfrm>
-            <a:off x="502920" y="384048"/>
-            <a:ext cx="1234440" cy="585216"/>
-          </a:xfrm>
-          <a:prstGeom prst="rect">
-            <a:avLst/>
-          </a:prstGeom>
-        </p:spPr>
-      </p:pic>
-      <p:sp>
-        <p:nvSpPr>
-          <p:cNvPr id="3" name="Text 0"/>
-          <p:cNvSpPr/>
-          <p:nvPr/>
-        </p:nvSpPr>
-        <p:spPr>
-          <a:xfrm>
-            <a:off x="10607040" y="411480"/>
-            <a:ext cx="1097280" cy="365760"/>
-          </a:xfrm>
-          <a:prstGeom prst="rect">
-            <a:avLst/>
-          </a:prstGeom>
-          <a:noFill/>
-          <a:ln/>
-        </p:spPr>
-        <p:txBody>
-          <a:bodyPr wrap="square" rtlCol="0" anchor="ctr"/>
-          <a:lstStyle/>
-          <a:p>
-            <a:pPr marL="0" indent="0" algn="r">
-              <a:buNone/>
-            </a:pPr>
-            <a:r>
-              <a:rPr lang="en-US" sz="1600" dirty="0">
-                <a:solidFill>
-                  <a:srgbClr val="D1D5DB"/>
-                </a:solidFill>
-                <a:latin typeface="Arial" pitchFamily="34" charset="0"/>
-                <a:ea typeface="Arial" pitchFamily="34" charset="-122"/>
-                <a:cs typeface="Arial" pitchFamily="34" charset="-120"/>
-              </a:rPr>
-              <a:t>09</a:t>
-            </a:r>
-            <a:endParaRPr lang="en-US" sz="1600" dirty="0"/>
-          </a:p>
-        </p:txBody>
-      </p:sp>
-      <p:sp>
-        <p:nvSpPr>
-          <p:cNvPr id="4" name="Text 1"/>
-          <p:cNvSpPr/>
-          <p:nvPr/>
-        </p:nvSpPr>
-        <p:spPr>
-          <a:xfrm>
-            <a:off x="502920" y="1234440"/>
-            <a:ext cx="11155680" cy="822960"/>
-          </a:xfrm>
-          <a:prstGeom prst="rect">
-            <a:avLst/>
-          </a:prstGeom>
-          <a:noFill/>
-          <a:ln/>
-        </p:spPr>
-        <p:txBody>
-          <a:bodyPr wrap="square" rtlCol="0" anchor="ctr"/>
-          <a:lstStyle/>
-          <a:p>
-            <a:pPr marL="0" indent="0">
-              <a:buNone/>
-            </a:pPr>
-            <a:r>
-              <a:rPr lang="en-US" sz="4000" kern="0" spc="-50" dirty="0">
-                <a:solidFill>
-                  <a:srgbClr val="FFFFFF"/>
-                </a:solidFill>
-                <a:latin typeface="Arial Black" pitchFamily="34" charset="0"/>
-                <a:ea typeface="Arial Black" pitchFamily="34" charset="-122"/>
-                <a:cs typeface="Arial Black" pitchFamily="34" charset="-120"/>
-              </a:rPr>
-              <a:t>RESUMO EXECUTIVO</a:t>
-            </a:r>
-            <a:endParaRPr lang="en-US" sz="4000" dirty="0"/>
-          </a:p>
-        </p:txBody>
-      </p:sp>
-      <p:sp>
-        <p:nvSpPr>
-          <p:cNvPr id="5" name="Shape 2"/>
-          <p:cNvSpPr/>
-          <p:nvPr/>
-        </p:nvSpPr>
-        <p:spPr>
-          <a:xfrm>
-            <a:off x="502920" y="2148840"/>
-            <a:ext cx="6035040" cy="713232"/>
-          </a:xfrm>
-          <a:prstGeom prst="roundRect">
-            <a:avLst>
-              <a:gd name="adj" fmla="val 10256"/>
-            </a:avLst>
-          </a:prstGeom>
-          <a:solidFill>
-            <a:srgbClr val="12294F"/>
-          </a:solidFill>
-          <a:ln w="12700">
-            <a:solidFill>
-              <a:srgbClr val="1E3A6B"/>
-            </a:solidFill>
-            <a:prstDash val="solid"/>
-          </a:ln>
-        </p:spPr>
-        <p:txBody>
-          <a:bodyPr/>
-          <a:lstStyle/>
-          <a:p>
-            <a:endParaRPr lang="pt-BR"/>
-          </a:p>
-        </p:txBody>
-      </p:sp>
-      <p:sp>
-        <p:nvSpPr>
-          <p:cNvPr id="6" name="Shape 3"/>
-          <p:cNvSpPr/>
-          <p:nvPr/>
-        </p:nvSpPr>
-        <p:spPr>
-          <a:xfrm>
-            <a:off x="502920" y="2148840"/>
-            <a:ext cx="82296" cy="713232"/>
-          </a:xfrm>
-          <a:prstGeom prst="rect">
-            <a:avLst/>
-          </a:prstGeom>
-          <a:solidFill>
-            <a:srgbClr val="F28C2B"/>
-          </a:solidFill>
-          <a:ln/>
-        </p:spPr>
-        <p:txBody>
-          <a:bodyPr/>
-          <a:lstStyle/>
-          <a:p>
-            <a:endParaRPr lang="pt-BR"/>
-          </a:p>
-        </p:txBody>
-      </p:sp>
-      <p:sp>
-        <p:nvSpPr>
-          <p:cNvPr id="7" name="Text 4"/>
-          <p:cNvSpPr/>
-          <p:nvPr/>
-        </p:nvSpPr>
-        <p:spPr>
-          <a:xfrm>
-            <a:off x="777240" y="2194560"/>
-            <a:ext cx="5486400" cy="292608"/>
-          </a:xfrm>
-          <a:prstGeom prst="rect">
-            <a:avLst/>
-          </a:prstGeom>
-          <a:noFill/>
-          <a:ln/>
-        </p:spPr>
-        <p:txBody>
-          <a:bodyPr wrap="square" rtlCol="0" anchor="ctr"/>
-          <a:lstStyle/>
-          <a:p>
-            <a:pPr marL="0" indent="0">
-              <a:buNone/>
-            </a:pPr>
-            <a:r>
-              <a:rPr lang="en-US" sz="1400" dirty="0">
-                <a:solidFill>
-                  <a:srgbClr val="D1D5DB"/>
-                </a:solidFill>
-                <a:latin typeface="Arial" pitchFamily="34" charset="0"/>
-                <a:ea typeface="Arial" pitchFamily="34" charset="-122"/>
-                <a:cs typeface="Arial" pitchFamily="34" charset="-120"/>
-              </a:rPr>
-              <a:t>Primeiro valor (21/05/2026)</a:t>
-            </a:r>
-            <a:endParaRPr lang="en-US" sz="1400" dirty="0"/>
-          </a:p>
-        </p:txBody>
-      </p:sp>
-      <p:sp>
-        <p:nvSpPr>
-          <p:cNvPr id="8" name="Text 5"/>
-          <p:cNvSpPr/>
-          <p:nvPr/>
-        </p:nvSpPr>
-        <p:spPr>
-          <a:xfrm>
-            <a:off x="777240" y="2468880"/>
-            <a:ext cx="5486400" cy="347472"/>
-          </a:xfrm>
-          <a:prstGeom prst="rect">
-            <a:avLst/>
-          </a:prstGeom>
-          <a:noFill/>
-          <a:ln/>
-        </p:spPr>
-        <p:txBody>
-          <a:bodyPr wrap="square" rtlCol="0" anchor="ctr"/>
-          <a:lstStyle/>
-          <a:p>
-            <a:pPr marL="0" indent="0">
-              <a:buNone/>
-            </a:pPr>
-            <a:r>
-              <a:rPr lang="en-US" sz="1900" b="1" dirty="0">
-                <a:solidFill>
-                  <a:srgbClr val="FFFFFF"/>
-                </a:solidFill>
-                <a:latin typeface="Arial" pitchFamily="34" charset="0"/>
-                <a:ea typeface="Arial" pitchFamily="34" charset="-122"/>
-                <a:cs typeface="Arial" pitchFamily="34" charset="-120"/>
-              </a:rPr>
-              <a:t>14,50%</a:t>
-            </a:r>
-            <a:endParaRPr lang="en-US" sz="1900" dirty="0"/>
-          </a:p>
-        </p:txBody>
-      </p:sp>
-      <p:sp>
-        <p:nvSpPr>
-          <p:cNvPr id="9" name="Shape 6"/>
-          <p:cNvSpPr/>
-          <p:nvPr/>
-        </p:nvSpPr>
-        <p:spPr>
-          <a:xfrm>
-            <a:off x="502920" y="2990088"/>
-            <a:ext cx="6035040" cy="713232"/>
-          </a:xfrm>
-          <a:prstGeom prst="roundRect">
-            <a:avLst>
-              <a:gd name="adj" fmla="val 10256"/>
-            </a:avLst>
-          </a:prstGeom>
-          <a:solidFill>
-            <a:srgbClr val="12294F"/>
-          </a:solidFill>
-          <a:ln w="12700">
-            <a:solidFill>
-              <a:srgbClr val="1E3A6B"/>
-            </a:solidFill>
-            <a:prstDash val="solid"/>
-          </a:ln>
-        </p:spPr>
-        <p:txBody>
-          <a:bodyPr/>
-          <a:lstStyle/>
-          <a:p>
-            <a:endParaRPr lang="pt-BR"/>
-          </a:p>
-        </p:txBody>
-      </p:sp>
-      <p:sp>
-        <p:nvSpPr>
-          <p:cNvPr id="10" name="Shape 7"/>
-          <p:cNvSpPr/>
-          <p:nvPr/>
-        </p:nvSpPr>
-        <p:spPr>
-          <a:xfrm>
-            <a:off x="502920" y="2990088"/>
-            <a:ext cx="82296" cy="713232"/>
-          </a:xfrm>
-          <a:prstGeom prst="rect">
-            <a:avLst/>
-          </a:prstGeom>
-          <a:solidFill>
-            <a:srgbClr val="F28C2B"/>
-          </a:solidFill>
-          <a:ln/>
-        </p:spPr>
-        <p:txBody>
-          <a:bodyPr/>
-          <a:lstStyle/>
-          <a:p>
-            <a:endParaRPr lang="pt-BR"/>
-          </a:p>
-        </p:txBody>
-      </p:sp>
-      <p:sp>
-        <p:nvSpPr>
-          <p:cNvPr id="11" name="Text 8"/>
-          <p:cNvSpPr/>
-          <p:nvPr/>
-        </p:nvSpPr>
-        <p:spPr>
-          <a:xfrm>
-            <a:off x="777240" y="3035808"/>
-            <a:ext cx="5486400" cy="292608"/>
-          </a:xfrm>
-          <a:prstGeom prst="rect">
-            <a:avLst/>
-          </a:prstGeom>
-          <a:noFill/>
-          <a:ln/>
-        </p:spPr>
-        <p:txBody>
-          <a:bodyPr wrap="square" rtlCol="0" anchor="ctr"/>
-          <a:lstStyle/>
-          <a:p>
-            <a:pPr marL="0" indent="0">
-              <a:buNone/>
-            </a:pPr>
-            <a:r>
-              <a:rPr lang="en-US" sz="1400" dirty="0">
-                <a:solidFill>
-                  <a:srgbClr val="D1D5DB"/>
-                </a:solidFill>
-                <a:latin typeface="Arial" pitchFamily="34" charset="0"/>
-                <a:ea typeface="Arial" pitchFamily="34" charset="-122"/>
-                <a:cs typeface="Arial" pitchFamily="34" charset="-120"/>
-              </a:rPr>
-              <a:t>Último valor (19/06/2026)</a:t>
-            </a:r>
-            <a:endParaRPr lang="en-US" sz="1400" dirty="0"/>
-          </a:p>
-        </p:txBody>
-      </p:sp>
-      <p:sp>
-        <p:nvSpPr>
-          <p:cNvPr id="12" name="Text 9"/>
-          <p:cNvSpPr/>
-          <p:nvPr/>
-        </p:nvSpPr>
-        <p:spPr>
-          <a:xfrm>
-            <a:off x="777240" y="3310128"/>
-            <a:ext cx="5486400" cy="347472"/>
-          </a:xfrm>
-          <a:prstGeom prst="rect">
-            <a:avLst/>
-          </a:prstGeom>
-          <a:noFill/>
-          <a:ln/>
-        </p:spPr>
-        <p:txBody>
-          <a:bodyPr wrap="square" rtlCol="0" anchor="ctr"/>
-          <a:lstStyle/>
-          <a:p>
-            <a:pPr marL="0" indent="0">
-              <a:buNone/>
-            </a:pPr>
-            <a:r>
-              <a:rPr lang="en-US" sz="1900" b="1" dirty="0">
-                <a:solidFill>
-                  <a:srgbClr val="FFFFFF"/>
-                </a:solidFill>
-                <a:latin typeface="Arial" pitchFamily="34" charset="0"/>
-                <a:ea typeface="Arial" pitchFamily="34" charset="-122"/>
-                <a:cs typeface="Arial" pitchFamily="34" charset="-120"/>
-              </a:rPr>
-              <a:t>14,75%</a:t>
-            </a:r>
-            <a:endParaRPr lang="en-US" sz="1900" dirty="0"/>
-          </a:p>
-        </p:txBody>
-      </p:sp>
-      <p:sp>
-        <p:nvSpPr>
-          <p:cNvPr id="13" name="Shape 10"/>
-          <p:cNvSpPr/>
-          <p:nvPr/>
-        </p:nvSpPr>
-        <p:spPr>
-          <a:xfrm>
-            <a:off x="502920" y="3831336"/>
-            <a:ext cx="6035040" cy="713232"/>
-          </a:xfrm>
-          <a:prstGeom prst="roundRect">
-            <a:avLst>
-              <a:gd name="adj" fmla="val 10256"/>
-            </a:avLst>
-          </a:prstGeom>
-          <a:solidFill>
-            <a:srgbClr val="12294F"/>
-          </a:solidFill>
-          <a:ln w="12700">
-            <a:solidFill>
-              <a:srgbClr val="1E3A6B"/>
-            </a:solidFill>
-            <a:prstDash val="solid"/>
-          </a:ln>
-        </p:spPr>
-        <p:txBody>
-          <a:bodyPr/>
-          <a:lstStyle/>
-          <a:p>
-            <a:endParaRPr lang="pt-BR"/>
-          </a:p>
-        </p:txBody>
-      </p:sp>
-      <p:sp>
-        <p:nvSpPr>
-          <p:cNvPr id="14" name="Shape 11"/>
-          <p:cNvSpPr/>
-          <p:nvPr/>
-        </p:nvSpPr>
-        <p:spPr>
-          <a:xfrm>
-            <a:off x="502920" y="3831336"/>
-            <a:ext cx="82296" cy="713232"/>
-          </a:xfrm>
-          <a:prstGeom prst="rect">
-            <a:avLst/>
-          </a:prstGeom>
-          <a:solidFill>
-            <a:srgbClr val="F28C2B"/>
-          </a:solidFill>
-          <a:ln/>
-        </p:spPr>
-        <p:txBody>
-          <a:bodyPr/>
-          <a:lstStyle/>
-          <a:p>
-            <a:endParaRPr lang="pt-BR"/>
-          </a:p>
-        </p:txBody>
-      </p:sp>
-      <p:sp>
-        <p:nvSpPr>
-          <p:cNvPr id="15" name="Text 12"/>
-          <p:cNvSpPr/>
-          <p:nvPr/>
-        </p:nvSpPr>
-        <p:spPr>
-          <a:xfrm>
-            <a:off x="777240" y="3877056"/>
-            <a:ext cx="5486400" cy="292608"/>
-          </a:xfrm>
-          <a:prstGeom prst="rect">
-            <a:avLst/>
-          </a:prstGeom>
-          <a:noFill/>
-          <a:ln/>
-        </p:spPr>
-        <p:txBody>
-          <a:bodyPr wrap="square" rtlCol="0" anchor="ctr"/>
-          <a:lstStyle/>
-          <a:p>
-            <a:pPr marL="0" indent="0">
-              <a:buNone/>
-            </a:pPr>
-            <a:r>
-              <a:rPr lang="en-US" sz="1400" dirty="0">
-                <a:solidFill>
-                  <a:srgbClr val="D1D5DB"/>
-                </a:solidFill>
-                <a:latin typeface="Arial" pitchFamily="34" charset="0"/>
-                <a:ea typeface="Arial" pitchFamily="34" charset="-122"/>
-                <a:cs typeface="Arial" pitchFamily="34" charset="-120"/>
-              </a:rPr>
-              <a:t>Variação no período</a:t>
-            </a:r>
-            <a:endParaRPr lang="en-US" sz="1400" dirty="0"/>
-          </a:p>
-        </p:txBody>
-      </p:sp>
-      <p:sp>
-        <p:nvSpPr>
-          <p:cNvPr id="16" name="Text 13"/>
-          <p:cNvSpPr/>
-          <p:nvPr/>
-        </p:nvSpPr>
-        <p:spPr>
-          <a:xfrm>
-            <a:off x="777240" y="4151376"/>
-            <a:ext cx="5486400" cy="347472"/>
-          </a:xfrm>
-          <a:prstGeom prst="rect">
-            <a:avLst/>
-          </a:prstGeom>
-          <a:noFill/>
-          <a:ln/>
-        </p:spPr>
-        <p:txBody>
-          <a:bodyPr wrap="square" rtlCol="0" anchor="ctr"/>
-          <a:lstStyle/>
-          <a:p>
-            <a:pPr marL="0" indent="0">
-              <a:buNone/>
-            </a:pPr>
-            <a:r>
-              <a:rPr lang="en-US" sz="1900" b="1" dirty="0">
-                <a:solidFill>
-                  <a:srgbClr val="4ADE80"/>
-                </a:solidFill>
-                <a:latin typeface="Arial" pitchFamily="34" charset="0"/>
-                <a:ea typeface="Arial" pitchFamily="34" charset="-122"/>
-                <a:cs typeface="Arial" pitchFamily="34" charset="-120"/>
-              </a:rPr>
-              <a:t>+0,25 p.p. (+1,72%)</a:t>
-            </a:r>
-            <a:endParaRPr lang="en-US" sz="1900" dirty="0"/>
-          </a:p>
-        </p:txBody>
-      </p:sp>
-      <p:sp>
-        <p:nvSpPr>
-          <p:cNvPr id="17" name="Shape 14"/>
-          <p:cNvSpPr/>
-          <p:nvPr/>
-        </p:nvSpPr>
-        <p:spPr>
-          <a:xfrm>
-            <a:off x="502920" y="4672584"/>
-            <a:ext cx="6035040" cy="713232"/>
-          </a:xfrm>
-          <a:prstGeom prst="roundRect">
-            <a:avLst>
-              <a:gd name="adj" fmla="val 10256"/>
-            </a:avLst>
-          </a:prstGeom>
-          <a:solidFill>
-            <a:srgbClr val="12294F"/>
-          </a:solidFill>
-          <a:ln w="12700">
-            <a:solidFill>
-              <a:srgbClr val="1E3A6B"/>
-            </a:solidFill>
-            <a:prstDash val="solid"/>
-          </a:ln>
-        </p:spPr>
-        <p:txBody>
-          <a:bodyPr/>
-          <a:lstStyle/>
-          <a:p>
-            <a:endParaRPr lang="pt-BR"/>
-          </a:p>
-        </p:txBody>
-      </p:sp>
-      <p:sp>
-        <p:nvSpPr>
-          <p:cNvPr id="18" name="Shape 15"/>
-          <p:cNvSpPr/>
-          <p:nvPr/>
-        </p:nvSpPr>
-        <p:spPr>
-          <a:xfrm>
-            <a:off x="502920" y="4672584"/>
-            <a:ext cx="82296" cy="713232"/>
-          </a:xfrm>
-          <a:prstGeom prst="rect">
-            <a:avLst/>
-          </a:prstGeom>
-          <a:solidFill>
-            <a:srgbClr val="F28C2B"/>
-          </a:solidFill>
-          <a:ln/>
-        </p:spPr>
-        <p:txBody>
-          <a:bodyPr/>
-          <a:lstStyle/>
-          <a:p>
-            <a:endParaRPr lang="pt-BR"/>
-          </a:p>
-        </p:txBody>
-      </p:sp>
-      <p:sp>
-        <p:nvSpPr>
-          <p:cNvPr id="19" name="Text 16"/>
-          <p:cNvSpPr/>
-          <p:nvPr/>
-        </p:nvSpPr>
-        <p:spPr>
-          <a:xfrm>
-            <a:off x="777240" y="4718304"/>
-            <a:ext cx="5486400" cy="292608"/>
-          </a:xfrm>
-          <a:prstGeom prst="rect">
-            <a:avLst/>
-          </a:prstGeom>
-          <a:noFill/>
-          <a:ln/>
-        </p:spPr>
-        <p:txBody>
-          <a:bodyPr wrap="square" rtlCol="0" anchor="ctr"/>
-          <a:lstStyle/>
-          <a:p>
-            <a:pPr marL="0" indent="0">
-              <a:buNone/>
-            </a:pPr>
-            <a:r>
-              <a:rPr lang="en-US" sz="1400" dirty="0">
-                <a:solidFill>
-                  <a:srgbClr val="D1D5DB"/>
-                </a:solidFill>
-                <a:latin typeface="Arial" pitchFamily="34" charset="0"/>
-                <a:ea typeface="Arial" pitchFamily="34" charset="-122"/>
-                <a:cs typeface="Arial" pitchFamily="34" charset="-120"/>
-              </a:rPr>
-              <a:t>Maior valor</a:t>
-            </a:r>
-            <a:endParaRPr lang="en-US" sz="1400" dirty="0"/>
-          </a:p>
-        </p:txBody>
-      </p:sp>
-      <p:sp>
-        <p:nvSpPr>
-          <p:cNvPr id="20" name="Text 17"/>
-          <p:cNvSpPr/>
-          <p:nvPr/>
-        </p:nvSpPr>
-        <p:spPr>
-          <a:xfrm>
-            <a:off x="777240" y="4992624"/>
-            <a:ext cx="5486400" cy="347472"/>
-          </a:xfrm>
-          <a:prstGeom prst="rect">
-            <a:avLst/>
-          </a:prstGeom>
-          <a:noFill/>
-          <a:ln/>
-        </p:spPr>
-        <p:txBody>
-          <a:bodyPr wrap="square" rtlCol="0" anchor="ctr"/>
-          <a:lstStyle/>
-          <a:p>
-            <a:pPr marL="0" indent="0">
-              <a:buNone/>
-            </a:pPr>
-            <a:r>
-              <a:rPr lang="en-US" sz="1900" b="1" dirty="0">
-                <a:solidFill>
-                  <a:srgbClr val="FFFFFF"/>
-                </a:solidFill>
-                <a:latin typeface="Arial" pitchFamily="34" charset="0"/>
-                <a:ea typeface="Arial" pitchFamily="34" charset="-122"/>
-                <a:cs typeface="Arial" pitchFamily="34" charset="-120"/>
-              </a:rPr>
-              <a:t>14,75%</a:t>
-            </a:r>
-            <a:endParaRPr lang="en-US" sz="1900" dirty="0"/>
-          </a:p>
-        </p:txBody>
-      </p:sp>
-      <p:sp>
-        <p:nvSpPr>
-          <p:cNvPr id="21" name="Shape 18"/>
-          <p:cNvSpPr/>
-          <p:nvPr/>
-        </p:nvSpPr>
-        <p:spPr>
-          <a:xfrm>
-            <a:off x="502920" y="5513832"/>
-            <a:ext cx="6035040" cy="713232"/>
-          </a:xfrm>
-          <a:prstGeom prst="roundRect">
-            <a:avLst>
-              <a:gd name="adj" fmla="val 10256"/>
-            </a:avLst>
-          </a:prstGeom>
-          <a:solidFill>
-            <a:srgbClr val="12294F"/>
-          </a:solidFill>
-          <a:ln w="12700">
-            <a:solidFill>
-              <a:srgbClr val="1E3A6B"/>
-            </a:solidFill>
-            <a:prstDash val="solid"/>
-          </a:ln>
-        </p:spPr>
-        <p:txBody>
-          <a:bodyPr/>
-          <a:lstStyle/>
-          <a:p>
-            <a:endParaRPr lang="pt-BR"/>
-          </a:p>
-        </p:txBody>
-      </p:sp>
-      <p:sp>
-        <p:nvSpPr>
-          <p:cNvPr id="22" name="Shape 19"/>
-          <p:cNvSpPr/>
-          <p:nvPr/>
-        </p:nvSpPr>
-        <p:spPr>
-          <a:xfrm>
-            <a:off x="502920" y="5513832"/>
-            <a:ext cx="82296" cy="713232"/>
-          </a:xfrm>
-          <a:prstGeom prst="rect">
-            <a:avLst/>
-          </a:prstGeom>
-          <a:solidFill>
-            <a:srgbClr val="F28C2B"/>
-          </a:solidFill>
-          <a:ln/>
-        </p:spPr>
-        <p:txBody>
-          <a:bodyPr/>
-          <a:lstStyle/>
-          <a:p>
-            <a:endParaRPr lang="pt-BR"/>
-          </a:p>
-        </p:txBody>
-      </p:sp>
-      <p:sp>
-        <p:nvSpPr>
-          <p:cNvPr id="23" name="Text 20"/>
-          <p:cNvSpPr/>
-          <p:nvPr/>
-        </p:nvSpPr>
-        <p:spPr>
-          <a:xfrm>
-            <a:off x="777240" y="5559552"/>
-            <a:ext cx="5486400" cy="292608"/>
-          </a:xfrm>
-          <a:prstGeom prst="rect">
-            <a:avLst/>
-          </a:prstGeom>
-          <a:noFill/>
-          <a:ln/>
-        </p:spPr>
-        <p:txBody>
-          <a:bodyPr wrap="square" rtlCol="0" anchor="ctr"/>
-          <a:lstStyle/>
-          <a:p>
-            <a:pPr marL="0" indent="0">
-              <a:buNone/>
-            </a:pPr>
-            <a:r>
-              <a:rPr lang="en-US" sz="1400" dirty="0">
-                <a:solidFill>
-                  <a:srgbClr val="D1D5DB"/>
-                </a:solidFill>
-                <a:latin typeface="Arial" pitchFamily="34" charset="0"/>
-                <a:ea typeface="Arial" pitchFamily="34" charset="-122"/>
-                <a:cs typeface="Arial" pitchFamily="34" charset="-120"/>
-              </a:rPr>
-              <a:t>Menor valor</a:t>
-            </a:r>
-            <a:endParaRPr lang="en-US" sz="1400" dirty="0"/>
-          </a:p>
-        </p:txBody>
-      </p:sp>
-      <p:sp>
-        <p:nvSpPr>
-          <p:cNvPr id="24" name="Text 21"/>
-          <p:cNvSpPr/>
-          <p:nvPr/>
-        </p:nvSpPr>
-        <p:spPr>
-          <a:xfrm>
-            <a:off x="777240" y="5833872"/>
-            <a:ext cx="5486400" cy="347472"/>
-          </a:xfrm>
-          <a:prstGeom prst="rect">
-            <a:avLst/>
-          </a:prstGeom>
-          <a:noFill/>
-          <a:ln/>
-        </p:spPr>
-        <p:txBody>
-          <a:bodyPr wrap="square" rtlCol="0" anchor="ctr"/>
-          <a:lstStyle/>
-          <a:p>
-            <a:pPr marL="0" indent="0">
-              <a:buNone/>
-            </a:pPr>
-            <a:r>
-              <a:rPr lang="en-US" sz="1900" b="1" dirty="0">
-                <a:solidFill>
-                  <a:srgbClr val="FFFFFF"/>
-                </a:solidFill>
-                <a:latin typeface="Arial" pitchFamily="34" charset="0"/>
-                <a:ea typeface="Arial" pitchFamily="34" charset="-122"/>
-                <a:cs typeface="Arial" pitchFamily="34" charset="-120"/>
-              </a:rPr>
-              <a:t>14,50%</a:t>
-            </a:r>
-            <a:endParaRPr lang="en-US" sz="1900" dirty="0"/>
-          </a:p>
-        </p:txBody>
-      </p:sp>
-      <p:sp>
-        <p:nvSpPr>
-          <p:cNvPr id="25" name="Text 22"/>
-          <p:cNvSpPr/>
-          <p:nvPr/>
-        </p:nvSpPr>
-        <p:spPr>
-          <a:xfrm>
-            <a:off x="7040880" y="2377440"/>
-            <a:ext cx="4572000" cy="1828800"/>
-          </a:xfrm>
-          <a:prstGeom prst="rect">
-            <a:avLst/>
-          </a:prstGeom>
-          <a:noFill/>
-          <a:ln/>
-        </p:spPr>
-        <p:txBody>
-          <a:bodyPr wrap="square" rtlCol="0" anchor="ctr"/>
-          <a:lstStyle/>
-          <a:p>
-            <a:pPr marL="0" indent="0">
-              <a:lnSpc>
-                <a:spcPts val="3000"/>
-              </a:lnSpc>
-              <a:buNone/>
-            </a:pPr>
-            <a:r>
-              <a:rPr lang="en-US" sz="1900" dirty="0">
-                <a:solidFill>
-                  <a:srgbClr val="D1D5DB"/>
-                </a:solidFill>
-                <a:latin typeface="Arial" pitchFamily="34" charset="0"/>
-                <a:ea typeface="Arial" pitchFamily="34" charset="-122"/>
-                <a:cs typeface="Arial" pitchFamily="34" charset="-120"/>
-              </a:rPr>
-              <a:t>A Selic anualizada base 252 apresentou alta de 0,25 ponto percentual nos últimos 30 dias, encerrando o período em 14,75%.</a:t>
-            </a:r>
-            <a:endParaRPr lang="en-US" sz="1900" dirty="0"/>
-          </a:p>
-        </p:txBody>
-      </p:sp>
     </p:spTree>
   </p:cSld>
   <p:clrMapOvr>

</xml_diff>

<commit_message>
docs: prompt curto do slide 06 reescrito e testado; quebras de linha do prompt corrigidas
- versao curta cobre os pontos em que a IA erra sem instrucao: dataInicial/dataFinal,
  aviso de contingencia (sem inventar dados), painel HTML offline com filtros
  funcionais, parametros.ini e cores BMA
- slide 06, apostila, guia, README e roteiro deixam claro que o slide e um resumo
  e que o prompt completo (QR) reproduz o robo da demonstracao
- prompt_oficina.txt estava com todas as quebras de linha duplicadas
- robo (codigo/) inalterado; instalador refeito so para levar os textos novos

Co-Authored-By: Claude Opus 5.5 <noreply@anthropic.com>
</commit_message>
<xml_diff>
--- a/apresentacao/BMA-Oficina-de-Robos.pptx
+++ b/apresentacao/BMA-Oficina-de-Robos.pptx
@@ -11153,7 +11153,7 @@
                 <a:ea typeface="Arial" pitchFamily="34" charset="-122"/>
                 <a:cs typeface="Arial" pitchFamily="34" charset="-120"/>
               </a:rPr>
-              <a:t>"Crie um programa em Python que consulte a API pública do Banco Central (SGS) e obtenha a Selic, série 1178, no período escolhido (padrão: últimos 12 meses).</a:t>
+              <a:t>"Crie um programa em Python que consulte a API SGS do Banco Central (série 1178, Selic) com dataInicial e dataFinal, no período escolhido (padrão: últimos 12 meses).</a:t>
             </a:r>
             <a:endParaRPr lang="en-US" sz="2000" dirty="0"/>
           </a:p>
@@ -11231,7 +11231,7 @@
                 <a:ea typeface="Arial" pitchFamily="34" charset="-122"/>
                 <a:cs typeface="Arial" pitchFamily="34" charset="-120"/>
               </a:rPr>
-              <a:t>•  Tratar erros e usar dados de contingência se a internet falhar</a:t>
+              <a:t>•  Se a internet falhar, usar a última consulta salva e avisar em destaque</a:t>
             </a:r>
             <a:endParaRPr lang="en-US" sz="1900" dirty="0"/>
           </a:p>
@@ -11270,7 +11270,7 @@
                 <a:ea typeface="Arial" pitchFamily="34" charset="-122"/>
                 <a:cs typeface="Arial" pitchFamily="34" charset="-120"/>
               </a:rPr>
-              <a:t>•  Mostrar um painel visual com gráficos e indicadores na tela</a:t>
+              <a:t>•  Abrir um painel HTML offline com indicadores, gráfico e filtros 1M/3M/12M funcionais</a:t>
             </a:r>
             <a:endParaRPr lang="en-US" sz="1900" dirty="0"/>
           </a:p>
@@ -11309,7 +11309,7 @@
                 <a:ea typeface="Arial" pitchFamily="34" charset="-122"/>
                 <a:cs typeface="Arial" pitchFamily="34" charset="-120"/>
               </a:rPr>
-              <a:t>•  Gerar Excel (Dados, Resumo e Mudanças), gráfico e relatório PDF</a:t>
+              <a:t>•  Gerar Excel (Dados, Resumo, Mudanças), gráfico e PDF em #1B172D/#F37522</a:t>
             </a:r>
             <a:endParaRPr lang="en-US" sz="1900" dirty="0"/>
           </a:p>
@@ -11348,7 +11348,7 @@
                 <a:ea typeface="Arial" pitchFamily="34" charset="-122"/>
                 <a:cs typeface="Arial" pitchFamily="34" charset="-120"/>
               </a:rPr>
-              <a:t>•  Registrar a execução em log e usar só bibliotecas gratuitas"</a:t>
+              <a:t>•  Ler o período de um parametros.ini, registrar log e usar só bibliotecas gratuitas"</a:t>
             </a:r>
             <a:endParaRPr lang="en-US" sz="1900" dirty="0"/>
           </a:p>
@@ -11387,7 +11387,7 @@
                 <a:ea typeface="Arial" pitchFamily="34" charset="-122"/>
                 <a:cs typeface="Arial" pitchFamily="34" charset="-120"/>
               </a:rPr>
-              <a:t>A </a:t>
+              <a:t>Resumo. Para o </a:t>
             </a:r>
             <a:r>
               <a:rPr lang="en-US" sz="2100" b="1" dirty="0">
@@ -11398,7 +11398,7 @@
                 <a:ea typeface="Arial" pitchFamily="34" charset="-122"/>
                 <a:cs typeface="Arial" pitchFamily="34" charset="-120"/>
               </a:rPr>
-              <a:t>IA gratuita </a:t>
+              <a:t>mesmo resultado</a:t>
             </a:r>
             <a:r>
               <a:rPr lang="en-US" sz="2100" b="1" dirty="0">
@@ -11409,7 +11409,7 @@
                 <a:ea typeface="Arial" pitchFamily="34" charset="-122"/>
                 <a:cs typeface="Arial" pitchFamily="34" charset="-120"/>
               </a:rPr>
-              <a:t>escreve o código para você.</a:t>
+              <a:t> da demo, use o prompt completo do QR Code.</a:t>
             </a:r>
             <a:endParaRPr lang="en-US" sz="2100" dirty="0"/>
           </a:p>

</xml_diff>